<commit_message>
Apply owner-confirmed pair activity and role rotation
</commit_message>
<xml_diff>
--- a/second-placement/planning/chapter-2-marketing-plan/2026-10-14-PEST-Piter-Run-Guide-v1.pptx
+++ b/second-placement/planning/chapter-2-marketing-plan/2026-10-14-PEST-Piter-Run-Guide-v1.pptx
@@ -2,24 +2,24 @@
 <file path=ppt/presentation.xml><?xml version="1.0" encoding="utf-8"?>
 <p:presentation xmlns:p="http://schemas.openxmlformats.org/presentationml/2006/main">
   <p:sldMasterIdLst>
-    <p:sldMasterId xmlns:r="http://schemas.openxmlformats.org/officeDocument/2006/relationships" id="2147483648" r:id="R86ede8e3ac614cc1"/>
+    <p:sldMasterId xmlns:r="http://schemas.openxmlformats.org/officeDocument/2006/relationships" id="2147483648" r:id="Raf7ac0934b0a4214"/>
   </p:sldMasterIdLst>
   <p:notesMasterIdLst>
-    <p:notesMasterId xmlns:r="http://schemas.openxmlformats.org/officeDocument/2006/relationships" r:id="Rba1b207513ae45d6"/>
+    <p:notesMasterId xmlns:r="http://schemas.openxmlformats.org/officeDocument/2006/relationships" r:id="R111d23d360ce4bcb"/>
   </p:notesMasterIdLst>
   <p:sldIdLst>
-    <p:sldId xmlns:r="http://schemas.openxmlformats.org/officeDocument/2006/relationships" id="256" r:id="R87f83ee4eed84b47"/>
-    <p:sldId xmlns:r="http://schemas.openxmlformats.org/officeDocument/2006/relationships" id="257" r:id="Rc9945bae55784802"/>
-    <p:sldId xmlns:r="http://schemas.openxmlformats.org/officeDocument/2006/relationships" id="258" r:id="R340af534ea45482d"/>
-    <p:sldId xmlns:r="http://schemas.openxmlformats.org/officeDocument/2006/relationships" id="259" r:id="R3a6673c06fca4fb2"/>
-    <p:sldId xmlns:r="http://schemas.openxmlformats.org/officeDocument/2006/relationships" id="260" r:id="R0ffa14aa3abd4160"/>
-    <p:sldId xmlns:r="http://schemas.openxmlformats.org/officeDocument/2006/relationships" id="261" r:id="R4315f597b97647a0"/>
-    <p:sldId xmlns:r="http://schemas.openxmlformats.org/officeDocument/2006/relationships" id="262" r:id="R8f3465be4d204007"/>
-    <p:sldId xmlns:r="http://schemas.openxmlformats.org/officeDocument/2006/relationships" id="263" r:id="Rab3577b977ae45c9"/>
-    <p:sldId xmlns:r="http://schemas.openxmlformats.org/officeDocument/2006/relationships" id="264" r:id="R54278e9b241e4357"/>
-    <p:sldId xmlns:r="http://schemas.openxmlformats.org/officeDocument/2006/relationships" id="265" r:id="Rd92862535edf46f6"/>
-    <p:sldId xmlns:r="http://schemas.openxmlformats.org/officeDocument/2006/relationships" id="266" r:id="Rfb5de551a4ad41af"/>
-    <p:sldId xmlns:r="http://schemas.openxmlformats.org/officeDocument/2006/relationships" id="267" r:id="R5e983b2235654b8c"/>
+    <p:sldId xmlns:r="http://schemas.openxmlformats.org/officeDocument/2006/relationships" id="256" r:id="R0a5ce51e492940af"/>
+    <p:sldId xmlns:r="http://schemas.openxmlformats.org/officeDocument/2006/relationships" id="257" r:id="R518dc50481b944ee"/>
+    <p:sldId xmlns:r="http://schemas.openxmlformats.org/officeDocument/2006/relationships" id="258" r:id="R171fca5b73c84fb7"/>
+    <p:sldId xmlns:r="http://schemas.openxmlformats.org/officeDocument/2006/relationships" id="259" r:id="R8672a1feb3bb4619"/>
+    <p:sldId xmlns:r="http://schemas.openxmlformats.org/officeDocument/2006/relationships" id="260" r:id="R6ab2166ad6984b88"/>
+    <p:sldId xmlns:r="http://schemas.openxmlformats.org/officeDocument/2006/relationships" id="261" r:id="Ra971b682859c4059"/>
+    <p:sldId xmlns:r="http://schemas.openxmlformats.org/officeDocument/2006/relationships" id="262" r:id="R7780be5539f145ff"/>
+    <p:sldId xmlns:r="http://schemas.openxmlformats.org/officeDocument/2006/relationships" id="263" r:id="Rdf29ce8ea6f7465a"/>
+    <p:sldId xmlns:r="http://schemas.openxmlformats.org/officeDocument/2006/relationships" id="264" r:id="Re2b8ac2c87484bc1"/>
+    <p:sldId xmlns:r="http://schemas.openxmlformats.org/officeDocument/2006/relationships" id="265" r:id="R152d58a92ff74013"/>
+    <p:sldId xmlns:r="http://schemas.openxmlformats.org/officeDocument/2006/relationships" id="266" r:id="R71cb09afc28b43e9"/>
+    <p:sldId xmlns:r="http://schemas.openxmlformats.org/officeDocument/2006/relationships" id="267" r:id="Rfd034a69f9634f48"/>
   </p:sldIdLst>
   <p:sldSz cx="12192000" cy="6858000"/>
   <p:notesSz cx="6858000" cy="9144000"/>
@@ -548,7 +548,7 @@
           </a:p>
           <a:p xmlns:a="http://schemas.openxmlformats.org/drawingml/2006/main">
             <a:r>
-              <a:t>DO: Read the category cue, start3min, stand at a deliberate scan point.</a:t>
+              <a:t>DO: Read the category cue, start a 3-minute timer, stand at a deliberate scan point.</a:t>
             </a:r>
           </a:p>
           <a:p xmlns:a="http://schemas.openxmlformats.org/drawingml/2006/main">
@@ -573,6 +573,11 @@
           </a:p>
           <a:p xmlns:a="http://schemas.openxmlformats.org/drawingml/2006/main">
             <a:r>
+              <a:t>PAIR MOVE: Give each partner a brief turn to explain an impact before recording the shared answer. Rotate roles at the next category.</a:t>
+            </a:r>
+          </a:p>
+          <a:p xmlns:a="http://schemas.openxmlformats.org/drawingml/2006/main">
+            <a:r>
               <a:t/>
             </a:r>
           </a:p>
@@ -653,7 +658,7 @@
           </a:p>
           <a:p xmlns:a="http://schemas.openxmlformats.org/drawingml/2006/main">
             <a:r>
-              <a:t>DO: Invite2–4complete sentences as a planning guide, not a scored word count. Students may orally rehearse first.</a:t>
+              <a:t>DO: Invite2–4 complete sentences as a planning guide, not a scored word count. Students may orally rehearse first.</a:t>
             </a:r>
           </a:p>
           <a:p xmlns:a="http://schemas.openxmlformats.org/drawingml/2006/main">
@@ -664,6 +669,11 @@
           <a:p xmlns:a="http://schemas.openxmlformats.org/drawingml/2006/main">
             <a:r>
               <a:t>EXTEND: Compare priorities or two interacting factors and justify a trade-off.</a:t>
+            </a:r>
+          </a:p>
+          <a:p xmlns:a="http://schemas.openxmlformats.org/drawingml/2006/main">
+            <a:r>
+              <a:t>PAIR CHECK: Both partners can explain the agreed business response.</a:t>
             </a:r>
           </a:p>
           <a:p xmlns:a="http://schemas.openxmlformats.org/drawingml/2006/main">
@@ -748,17 +758,17 @@
           </a:p>
           <a:p xmlns:a="http://schemas.openxmlformats.org/drawingml/2006/main">
             <a:r>
-              <a:t>DO: Record separate Block1 and Block5 stops.</a:t>
+              <a:t>DO: Record separate Block 1 and Block 5 stops.</a:t>
             </a:r>
           </a:p>
           <a:p xmlns:a="http://schemas.openxmlformats.org/drawingml/2006/main">
             <a:r>
-              <a:t>OPEN: Confirm quiz scope, collection route, individual/pair arrangement, and grading with Pat. Do not invent a deadline.</a:t>
+              <a:t>OPEN: Confirm quiz scope, collection route, how pair evidence will be assessed, and grading with Pat. Do not invent a deadline.</a:t>
             </a:r>
           </a:p>
           <a:p xmlns:a="http://schemas.openxmlformats.org/drawingml/2006/main">
             <a:r>
-              <a:t>RECORD: Block1 stop/support needed __ ; Block5 stop/support needed __.</a:t>
+              <a:t>RECORD: Block 1 stop/support needed __ ; Block 5 stop/support needed __.</a:t>
             </a:r>
           </a:p>
           <a:p xmlns:a="http://schemas.openxmlformats.org/drawingml/2006/main">
@@ -848,7 +858,7 @@
           </a:p>
           <a:p xmlns:a="http://schemas.openxmlformats.org/drawingml/2006/main">
             <a:r>
-              <a:t>NOTE: 3–5 + 2 + 12 + 5 =22–24, leaving6–8minutes. If discussion runs longer, reduce buffer rather than claiming work finished.</a:t>
+              <a:t>NOTE: 3–5 + 2 + 12 + 5 =22–24, leaving 6–8 minutes. If discussion runs longer, reduce buffer rather than claiming work finished.</a:t>
             </a:r>
           </a:p>
           <a:p xmlns:a="http://schemas.openxmlformats.org/drawingml/2006/main">
@@ -1023,7 +1033,7 @@
           </a:p>
           <a:p xmlns:a="http://schemas.openxmlformats.org/drawingml/2006/main">
             <a:r>
-              <a:t>ASSESS: Understanding, not spelling, handwriting, accent, speed, or decorative work. Access support alone never reduces a level. Insufficient evidence is separate from level1; confirm IE and overall-score handling with Pat.</a:t>
+              <a:t>ASSESS: Understanding, not spelling, handwriting, accent, speed, or decorative work. Access support alone never reduces a level. Insufficient evidence is separate from level 1; confirm IE and overall-score handling with Pat.</a:t>
             </a:r>
           </a:p>
           <a:p xmlns:a="http://schemas.openxmlformats.org/drawingml/2006/main">
@@ -1198,7 +1208,7 @@
           </a:p>
           <a:p xmlns:a="http://schemas.openxmlformats.org/drawingml/2006/main">
             <a:r>
-              <a:t>DO: Start2min timer. If stuck, offer a familiar business category such as a cafe, shoe shop, or digital-book service.</a:t>
+              <a:t>DO: Start a 2-minute timer. If stuck, offer a familiar business category such as a cafe, shoe shop, or digital-book service.</a:t>
             </a:r>
           </a:p>
           <a:p xmlns:a="http://schemas.openxmlformats.org/drawingml/2006/main">
@@ -1288,7 +1298,7 @@
           </a:p>
           <a:p xmlns:a="http://schemas.openxmlformats.org/drawingml/2006/main">
             <a:r>
-              <a:t>DO: Read the category cue, start3min, stand at a deliberate scan point.</a:t>
+              <a:t>DO: Read the category cue, start a 3-minute timer, stand at a deliberate scan point.</a:t>
             </a:r>
           </a:p>
           <a:p xmlns:a="http://schemas.openxmlformats.org/drawingml/2006/main">
@@ -1313,6 +1323,11 @@
           </a:p>
           <a:p xmlns:a="http://schemas.openxmlformats.org/drawingml/2006/main">
             <a:r>
+              <a:t>PAIR MOVE: Give each partner a brief turn to explain an impact before recording the shared answer. Rotate roles at the next category.</a:t>
+            </a:r>
+          </a:p>
+          <a:p xmlns:a="http://schemas.openxmlformats.org/drawingml/2006/main">
+            <a:r>
               <a:t/>
             </a:r>
           </a:p>
@@ -1393,7 +1408,7 @@
           </a:p>
           <a:p xmlns:a="http://schemas.openxmlformats.org/drawingml/2006/main">
             <a:r>
-              <a:t>DO: Read the category cue, start3min, stand at a deliberate scan point.</a:t>
+              <a:t>DO: Read the category cue, start a 3-minute timer, stand at a deliberate scan point.</a:t>
             </a:r>
           </a:p>
           <a:p xmlns:a="http://schemas.openxmlformats.org/drawingml/2006/main">
@@ -1418,6 +1433,11 @@
           </a:p>
           <a:p xmlns:a="http://schemas.openxmlformats.org/drawingml/2006/main">
             <a:r>
+              <a:t>PAIR MOVE: Give each partner a brief turn to explain an impact before recording the shared answer. Rotate roles at the next category.</a:t>
+            </a:r>
+          </a:p>
+          <a:p xmlns:a="http://schemas.openxmlformats.org/drawingml/2006/main">
+            <a:r>
               <a:t/>
             </a:r>
           </a:p>
@@ -1498,7 +1518,7 @@
           </a:p>
           <a:p xmlns:a="http://schemas.openxmlformats.org/drawingml/2006/main">
             <a:r>
-              <a:t>DO: Read the category cue, start3min, stand at a deliberate scan point.</a:t>
+              <a:t>DO: Read the category cue, start a 3-minute timer, stand at a deliberate scan point.</a:t>
             </a:r>
           </a:p>
           <a:p xmlns:a="http://schemas.openxmlformats.org/drawingml/2006/main">
@@ -1523,6 +1543,11 @@
           </a:p>
           <a:p xmlns:a="http://schemas.openxmlformats.org/drawingml/2006/main">
             <a:r>
+              <a:t>PAIR MOVE: Give each partner a brief turn to explain an impact before recording the shared answer. Rotate roles at the next category.</a:t>
+            </a:r>
+          </a:p>
+          <a:p xmlns:a="http://schemas.openxmlformats.org/drawingml/2006/main">
+            <a:r>
               <a:t/>
             </a:r>
           </a:p>
@@ -1575,7 +1600,7 @@
           <p:cNvPr id="3" name="Title">
             <a:extLst xmlns:a="http://schemas.openxmlformats.org/drawingml/2006/main">
               <a:ext uri="{FF2B5EF4-FFF2-40B4-BE49-F238E27FC236}">
-                <a16:creationId xmlns:a16="http://schemas.microsoft.com/office/drawing/2014/main" id="{33A928B0-5662-437C-B1A9-9FBC2DABDA50}"/>
+                <a16:creationId xmlns:a16="http://schemas.microsoft.com/office/drawing/2014/main" id="{E91005FD-660F-4C9A-B85C-DB0B9ABBC9D7}"/>
               </a:ext>
             </a:extLst>
           </p:cNvPr>
@@ -1732,7 +1757,7 @@
           <p:cNvPr id="2" name="Subtitle">
             <a:extLst xmlns:a="http://schemas.openxmlformats.org/drawingml/2006/main">
               <a:ext uri="{FF2B5EF4-FFF2-40B4-BE49-F238E27FC236}">
-                <a16:creationId xmlns:a16="http://schemas.microsoft.com/office/drawing/2014/main" id="{C5BE5248-3B68-4283-9A0B-F42635819BAD}"/>
+                <a16:creationId xmlns:a16="http://schemas.microsoft.com/office/drawing/2014/main" id="{C6F45A8E-87FA-49F8-B35E-A8602EB6A47B}"/>
               </a:ext>
             </a:extLst>
           </p:cNvPr>
@@ -1906,7 +1931,7 @@
           <p:cNvPr id="2" name="Section title">
             <a:extLst xmlns:a="http://schemas.openxmlformats.org/drawingml/2006/main">
               <a:ext uri="{FF2B5EF4-FFF2-40B4-BE49-F238E27FC236}">
-                <a16:creationId xmlns:a16="http://schemas.microsoft.com/office/drawing/2014/main" id="{B03AE8C6-775A-442F-B32E-4BD8BE752F24}"/>
+                <a16:creationId xmlns:a16="http://schemas.microsoft.com/office/drawing/2014/main" id="{72840F05-BD43-43AA-85E7-1BCC7F630C66}"/>
               </a:ext>
             </a:extLst>
           </p:cNvPr>
@@ -2080,7 +2105,7 @@
           <p:cNvPr id="3" name="Title">
             <a:extLst xmlns:a="http://schemas.openxmlformats.org/drawingml/2006/main">
               <a:ext uri="{FF2B5EF4-FFF2-40B4-BE49-F238E27FC236}">
-                <a16:creationId xmlns:a16="http://schemas.microsoft.com/office/drawing/2014/main" id="{CA37C734-C59D-45F0-AD0B-8DEB055085D7}"/>
+                <a16:creationId xmlns:a16="http://schemas.microsoft.com/office/drawing/2014/main" id="{32CCD2CE-E6E7-45BA-9434-8514BF88BF35}"/>
               </a:ext>
             </a:extLst>
           </p:cNvPr>
@@ -2237,7 +2262,7 @@
           <p:cNvPr id="2" name="Body">
             <a:extLst xmlns:a="http://schemas.openxmlformats.org/drawingml/2006/main">
               <a:ext uri="{FF2B5EF4-FFF2-40B4-BE49-F238E27FC236}">
-                <a16:creationId xmlns:a16="http://schemas.microsoft.com/office/drawing/2014/main" id="{09F3CFD9-47F0-4162-97A6-81DEECEE0730}"/>
+                <a16:creationId xmlns:a16="http://schemas.microsoft.com/office/drawing/2014/main" id="{A356F3DC-ECCB-42E2-BD0F-6F3EA5825850}"/>
               </a:ext>
             </a:extLst>
           </p:cNvPr>
@@ -2411,7 +2436,7 @@
           <p:cNvPr id="4" name="Title">
             <a:extLst xmlns:a="http://schemas.openxmlformats.org/drawingml/2006/main">
               <a:ext uri="{FF2B5EF4-FFF2-40B4-BE49-F238E27FC236}">
-                <a16:creationId xmlns:a16="http://schemas.microsoft.com/office/drawing/2014/main" id="{0FE6C24F-EAF7-41ED-8845-B61CE5F376A4}"/>
+                <a16:creationId xmlns:a16="http://schemas.microsoft.com/office/drawing/2014/main" id="{6184D157-5195-431C-AFE1-9741D8F8A333}"/>
               </a:ext>
             </a:extLst>
           </p:cNvPr>
@@ -2568,7 +2593,7 @@
           <p:cNvPr id="2" name="Left column">
             <a:extLst xmlns:a="http://schemas.openxmlformats.org/drawingml/2006/main">
               <a:ext uri="{FF2B5EF4-FFF2-40B4-BE49-F238E27FC236}">
-                <a16:creationId xmlns:a16="http://schemas.microsoft.com/office/drawing/2014/main" id="{3FCE65AE-649F-4EEB-B93A-A413A838F848}"/>
+                <a16:creationId xmlns:a16="http://schemas.microsoft.com/office/drawing/2014/main" id="{B509F7C7-7C64-4911-97A4-84AD962CECED}"/>
               </a:ext>
             </a:extLst>
           </p:cNvPr>
@@ -2725,7 +2750,7 @@
           <p:cNvPr id="3" name="Right column">
             <a:extLst xmlns:a="http://schemas.openxmlformats.org/drawingml/2006/main">
               <a:ext uri="{FF2B5EF4-FFF2-40B4-BE49-F238E27FC236}">
-                <a16:creationId xmlns:a16="http://schemas.microsoft.com/office/drawing/2014/main" id="{80305715-3D58-4878-BFA4-BA1AF6FF9CF4}"/>
+                <a16:creationId xmlns:a16="http://schemas.microsoft.com/office/drawing/2014/main" id="{4F9964BA-A02F-4479-963A-4888205BB33F}"/>
               </a:ext>
             </a:extLst>
           </p:cNvPr>
@@ -2899,7 +2924,7 @@
           <p:cNvPr id="3" name="Title">
             <a:extLst xmlns:a="http://schemas.openxmlformats.org/drawingml/2006/main">
               <a:ext uri="{FF2B5EF4-FFF2-40B4-BE49-F238E27FC236}">
-                <a16:creationId xmlns:a16="http://schemas.microsoft.com/office/drawing/2014/main" id="{43604754-C656-4B63-AE67-D25DCD0A1C89}"/>
+                <a16:creationId xmlns:a16="http://schemas.microsoft.com/office/drawing/2014/main" id="{0E2A90D3-BDBF-4454-9B94-488F882E771D}"/>
               </a:ext>
             </a:extLst>
           </p:cNvPr>
@@ -3056,7 +3081,7 @@
           <p:cNvPr id="2" name="Left column">
             <a:extLst xmlns:a="http://schemas.openxmlformats.org/drawingml/2006/main">
               <a:ext uri="{FF2B5EF4-FFF2-40B4-BE49-F238E27FC236}">
-                <a16:creationId xmlns:a16="http://schemas.microsoft.com/office/drawing/2014/main" id="{1FF040D6-4791-4C32-AC18-61CD6ECABD1C}"/>
+                <a16:creationId xmlns:a16="http://schemas.microsoft.com/office/drawing/2014/main" id="{DF36E99E-F4B6-4F2D-BE96-1497A1D29464}"/>
               </a:ext>
             </a:extLst>
           </p:cNvPr>
@@ -3251,12 +3276,12 @@
   </p:cSld>
   <p:clrMap bg1="lt1" tx1="dk1" bg2="lt2" tx2="dk2" accent1="accent1" accent2="accent2" accent3="accent3" accent4="accent4" accent5="accent5" accent6="accent6" hlink="hlink" folHlink="folHlink"/>
   <p:sldLayoutIdLst>
-    <p:sldLayoutId xmlns:r="http://schemas.openxmlformats.org/officeDocument/2006/relationships" id="2147483649" r:id="Rb1e0fec742c74c63"/>
-    <p:sldLayoutId xmlns:r="http://schemas.openxmlformats.org/officeDocument/2006/relationships" id="2147483650" r:id="R7c93692136d04bc3"/>
-    <p:sldLayoutId xmlns:r="http://schemas.openxmlformats.org/officeDocument/2006/relationships" id="2147483651" r:id="R05c209a426014c8c"/>
-    <p:sldLayoutId xmlns:r="http://schemas.openxmlformats.org/officeDocument/2006/relationships" id="2147483652" r:id="R063f60df7f7d4f38"/>
-    <p:sldLayoutId xmlns:r="http://schemas.openxmlformats.org/officeDocument/2006/relationships" id="2147483653" r:id="R942540f2d6864264"/>
-    <p:sldLayoutId xmlns:r="http://schemas.openxmlformats.org/officeDocument/2006/relationships" id="2147483654" r:id="R47d87987a7384e35"/>
+    <p:sldLayoutId xmlns:r="http://schemas.openxmlformats.org/officeDocument/2006/relationships" id="2147483649" r:id="Rc4ceb14e12bd4506"/>
+    <p:sldLayoutId xmlns:r="http://schemas.openxmlformats.org/officeDocument/2006/relationships" id="2147483650" r:id="Red82860eda9c4b27"/>
+    <p:sldLayoutId xmlns:r="http://schemas.openxmlformats.org/officeDocument/2006/relationships" id="2147483651" r:id="R8b2d54f67eab47fd"/>
+    <p:sldLayoutId xmlns:r="http://schemas.openxmlformats.org/officeDocument/2006/relationships" id="2147483652" r:id="R8172b3a8dd844a50"/>
+    <p:sldLayoutId xmlns:r="http://schemas.openxmlformats.org/officeDocument/2006/relationships" id="2147483653" r:id="R95f4d958e59b4e83"/>
+    <p:sldLayoutId xmlns:r="http://schemas.openxmlformats.org/officeDocument/2006/relationships" id="2147483654" r:id="Rb687d839e88647d7"/>
   </p:sldLayoutIdLst>
   <p:txStyles>
     <p:titleStyle>
@@ -3807,7 +3832,7 @@
           <p:cNvPr id="4" name="">
             <ns1:extLst>
               <ns1:ext uri="{FF2B5EF4-FFF2-40B4-BE49-F238E27FC236}">
-                <ns2:creationId id="{4CB9E989-A205-46C6-B3D8-7B6EDC100644}"/>
+                <ns2:creationId id="{D5F34E39-F88B-4864-BA3C-070D3A8896DD}"/>
               </ns1:ext>
             </ns1:extLst>
           </p:cNvPr>
@@ -3873,7 +3898,7 @@
           <p:cNvPr id="2" name="">
             <ns1:extLst>
               <ns1:ext uri="{FF2B5EF4-FFF2-40B4-BE49-F238E27FC236}">
-                <ns2:creationId id="{2EC03EB6-3B24-48C0-A2DA-CDF04002F5C0}"/>
+                <ns2:creationId id="{64213D36-2E31-4203-BB5D-404E3928806C}"/>
               </ns1:ext>
             </ns1:extLst>
           </p:cNvPr>
@@ -3939,7 +3964,7 @@
           <p:cNvPr id="3" name="">
             <ns1:extLst>
               <ns1:ext uri="{FF2B5EF4-FFF2-40B4-BE49-F238E27FC236}">
-                <ns2:creationId id="{6253066E-AE0A-4B31-86E9-F411A911505A}"/>
+                <ns2:creationId id="{D15BD7F2-AF2B-4FB8-BDF1-9E2688198F98}"/>
               </ns1:ext>
             </ns1:extLst>
           </p:cNvPr>
@@ -4059,7 +4084,7 @@
     </p:spTree>
     <p:extLst>
       <p:ext uri="{BB962C8B-B14F-4D97-AF65-F5344CB8AC3E}">
-        <ns3:creationId val="982108429"/>
+        <ns3:creationId val="1765780660"/>
       </p:ext>
     </p:extLst>
   </p:cSld>
@@ -4093,7 +4118,7 @@
           <p:cNvPr id="4" name="">
             <ns1:extLst>
               <ns1:ext uri="{FF2B5EF4-FFF2-40B4-BE49-F238E27FC236}">
-                <ns2:creationId id="{89E1B7A0-767C-401E-95A0-30EA5A8CD0F0}"/>
+                <ns2:creationId id="{F347CB34-913A-46F9-A22F-4A86E2D51777}"/>
               </ns1:ext>
             </ns1:extLst>
           </p:cNvPr>
@@ -4159,7 +4184,7 @@
           <p:cNvPr id="2" name="">
             <ns1:extLst>
               <ns1:ext uri="{FF2B5EF4-FFF2-40B4-BE49-F238E27FC236}">
-                <ns2:creationId id="{68699B88-5350-4EBC-BD58-CB3C01135525}"/>
+                <ns2:creationId id="{20B679BF-0C49-475B-B0CF-4B1C64F55CF7}"/>
               </ns1:ext>
             </ns1:extLst>
           </p:cNvPr>
@@ -4225,7 +4250,7 @@
           <p:cNvPr id="3" name="">
             <ns1:extLst>
               <ns1:ext uri="{FF2B5EF4-FFF2-40B4-BE49-F238E27FC236}">
-                <ns2:creationId id="{23B369D9-F648-40E1-8701-6E28F9515529}"/>
+                <ns2:creationId id="{FC32B38C-8ABE-43F1-9786-758A062C0629}"/>
               </ns1:ext>
             </ns1:extLst>
           </p:cNvPr>
@@ -4309,7 +4334,7 @@
                 <ns1:ea typeface="Helvetica Neue"/>
                 <ns1:cs typeface="Helvetica Neue"/>
               </ns1:rPr>
-              <ns1:t>DO: Read the category cue, start3min, stand at a deliberate scan point.</ns1:t>
+              <ns1:t>DO: Start a 3-minute timer. Each partner explains an impact. Record the shared answer and switch roles for the next category.</ns1:t>
             </ns1:r>
           </ns1:p>
           <ns1:p>
@@ -4337,7 +4362,7 @@
                 <ns1:ea typeface="Helvetica Neue"/>
                 <ns1:cs typeface="Helvetica Neue"/>
               </ns1:rPr>
-              <ns1:t>LISTEN FOR: External factor, category fit, effect on this business or target market, because reasoning.</ns1:t>
+              <ns1:t>LOOK FOR: External factor, correct category, business impact, and a because explanation.</ns1:t>
             </ns1:r>
           </ns1:p>
           <ns1:p>
@@ -4365,7 +4390,7 @@
                 <ns1:ea typeface="Helvetica Neue"/>
                 <ns1:cs typeface="Helvetica Neue"/>
               </ns1:rPr>
-              <ns1:t>IF WEAK: Ask “What changed outside the business? What happens to costs, customers, or access?” Model a question, not their answer.</ns1:t>
+              <ns1:t>SUPPORT: Ask what changed outside the business and what happens to costs, customers, or access.</ns1:t>
             </ns1:r>
           </ns1:p>
           <ns1:p>
@@ -4393,7 +4418,7 @@
                 <ns1:ea typeface="Helvetica Neue"/>
                 <ns1:cs typeface="Helvetica Neue"/>
               </ns1:rPr>
-              <ns1:t>IF STRONG: Ask which impact matters most and why.</ns1:t>
+              <ns1:t>EXTEND: Ask which impact matters most and why.</ns1:t>
             </ns1:r>
           </ns1:p>
           <ns1:p>
@@ -4421,7 +4446,7 @@
                 <ns1:ea typeface="Helvetica Neue"/>
                 <ns1:cs typeface="Helvetica Neue"/>
               </ns1:rPr>
-              <ns1:t>CHECK: Do not classify the business’s own ad, discount, or new app decision as the external factor.</ns1:t>
+              <ns1:t>CHECK: An ad, discount, or app chosen by the business is its internal response, not the external factor.</ns1:t>
             </ns1:r>
           </ns1:p>
         </p:txBody>
@@ -4429,7 +4454,7 @@
     </p:spTree>
     <p:extLst>
       <p:ext uri="{BB962C8B-B14F-4D97-AF65-F5344CB8AC3E}">
-        <ns3:creationId val="1332693276"/>
+        <ns3:creationId val="364950419"/>
       </p:ext>
     </p:extLst>
   </p:cSld>
@@ -4463,7 +4488,7 @@
           <p:cNvPr id="4" name="">
             <ns1:extLst>
               <ns1:ext uri="{FF2B5EF4-FFF2-40B4-BE49-F238E27FC236}">
-                <ns2:creationId id="{214F0D9C-0B6C-4FC5-B728-B26F75CB876A}"/>
+                <ns2:creationId id="{3253630C-45A7-4179-BFC9-84C8E9A24E11}"/>
               </ns1:ext>
             </ns1:extLst>
           </p:cNvPr>
@@ -4529,7 +4554,7 @@
           <p:cNvPr id="2" name="">
             <ns1:extLst>
               <ns1:ext uri="{FF2B5EF4-FFF2-40B4-BE49-F238E27FC236}">
-                <ns2:creationId id="{710A73B4-48DF-4AB1-ACAD-C089F4876CED}"/>
+                <ns2:creationId id="{62291E7B-F9B1-44E2-8ED1-28CE7D57ACFF}"/>
               </ns1:ext>
             </ns1:extLst>
           </p:cNvPr>
@@ -4595,7 +4620,7 @@
           <p:cNvPr id="3" name="">
             <ns1:extLst>
               <ns1:ext uri="{FF2B5EF4-FFF2-40B4-BE49-F238E27FC236}">
-                <ns2:creationId id="{A5E94556-3F8A-4170-964D-1B3743E382B8}"/>
+                <ns2:creationId id="{3E8D7BD2-179B-42DB-853B-FA6C6E2BD912}"/>
               </ns1:ext>
             </ns1:extLst>
           </p:cNvPr>
@@ -4679,7 +4704,7 @@
                 <ns1:ea typeface="Helvetica Neue"/>
                 <ns1:cs typeface="Helvetica Neue"/>
               </ns1:rPr>
-              <ns1:t>DO: Invite2–4complete sentences as a planning guide, not a scored word count. Students may orally rehearse first.</ns1:t>
+              <ns1:t>DO: Invite2–4 complete sentences as a planning guide, not a scored word count. Students may orally rehearse first.</ns1:t>
             </ns1:r>
           </ns1:p>
           <ns1:p>
@@ -4736,6 +4761,34 @@
                 <ns1:cs typeface="Helvetica Neue"/>
               </ns1:rPr>
               <ns1:t>EXTEND: Compare priorities or two interacting factors and justify a trade-off.</ns1:t>
+            </ns1:r>
+          </ns1:p>
+          <ns1:p>
+            <ns1:r>
+              <ns1:t/>
+            </ns1:r>
+          </ns1:p>
+          <ns1:p>
+            <ns1:pPr>
+              <ns1:defRPr sz="1875" b="0">
+                <ns1:solidFill>
+                  <ns1:srgbClr val="142C40"/>
+                </ns1:solidFill>
+                <ns1:latin typeface="Helvetica Neue"/>
+                <ns1:ea typeface="Helvetica Neue"/>
+                <ns1:cs typeface="Helvetica Neue"/>
+              </ns1:defRPr>
+            </ns1:pPr>
+            <ns1:r>
+              <ns1:rPr sz="1875" b="0">
+                <ns1:solidFill>
+                  <ns1:srgbClr val="142C40"/>
+                </ns1:solidFill>
+                <ns1:latin typeface="Helvetica Neue"/>
+                <ns1:ea typeface="Helvetica Neue"/>
+                <ns1:cs typeface="Helvetica Neue"/>
+              </ns1:rPr>
+              <ns1:t>PAIR CHECK: Both partners can explain the agreed business response.</ns1:t>
             </ns1:r>
           </ns1:p>
         </p:txBody>
@@ -4743,7 +4796,7 @@
     </p:spTree>
     <p:extLst>
       <p:ext uri="{BB962C8B-B14F-4D97-AF65-F5344CB8AC3E}">
-        <ns3:creationId val="2059742946"/>
+        <ns3:creationId val="1887358174"/>
       </p:ext>
     </p:extLst>
   </p:cSld>
@@ -4777,7 +4830,7 @@
           <p:cNvPr id="4" name="">
             <ns1:extLst>
               <ns1:ext uri="{FF2B5EF4-FFF2-40B4-BE49-F238E27FC236}">
-                <ns2:creationId id="{E02B1244-2DC7-44F6-B291-309AD307F0A2}"/>
+                <ns2:creationId id="{6E1119B4-4A34-422C-AC77-DD4200D77976}"/>
               </ns1:ext>
             </ns1:extLst>
           </p:cNvPr>
@@ -4843,7 +4896,7 @@
           <p:cNvPr id="2" name="">
             <ns1:extLst>
               <ns1:ext uri="{FF2B5EF4-FFF2-40B4-BE49-F238E27FC236}">
-                <ns2:creationId id="{7761FE40-C7C0-416C-83BB-08ACA015C509}"/>
+                <ns2:creationId id="{1FA8F061-18C0-4950-B889-25A5A7464A08}"/>
               </ns1:ext>
             </ns1:extLst>
           </p:cNvPr>
@@ -4909,7 +4962,7 @@
           <p:cNvPr id="3" name="">
             <ns1:extLst>
               <ns1:ext uri="{FF2B5EF4-FFF2-40B4-BE49-F238E27FC236}">
-                <ns2:creationId id="{0CA93929-2F60-4642-BFA1-03C1B2A754E3}"/>
+                <ns2:creationId id="{705412C2-8B02-4315-99DD-E4733A3D0829}"/>
               </ns1:ext>
             </ns1:extLst>
           </p:cNvPr>
@@ -4993,7 +5046,7 @@
                 <ns1:ea typeface="Helvetica Neue"/>
                 <ns1:cs typeface="Helvetica Neue"/>
               </ns1:rPr>
-              <ns1:t>DO: Record separate Block1 and Block5 stops.</ns1:t>
+              <ns1:t>DO: Record separate Block 1 and Block 5 stops.</ns1:t>
             </ns1:r>
           </ns1:p>
           <ns1:p>
@@ -5021,7 +5074,7 @@
                 <ns1:ea typeface="Helvetica Neue"/>
                 <ns1:cs typeface="Helvetica Neue"/>
               </ns1:rPr>
-              <ns1:t>OPEN: Confirm quiz scope, collection route, individual/pair arrangement, and grading with Pat. Do not invent a deadline.</ns1:t>
+              <ns1:t>OPEN: Confirm quiz scope, collection route, how pair evidence will be assessed, and grading with Pat. Do not invent a deadline.</ns1:t>
             </ns1:r>
           </ns1:p>
           <ns1:p>
@@ -5049,7 +5102,7 @@
                 <ns1:ea typeface="Helvetica Neue"/>
                 <ns1:cs typeface="Helvetica Neue"/>
               </ns1:rPr>
-              <ns1:t>RECORD: Block1 stop/support needed __ ; Block5 stop/support needed __.</ns1:t>
+              <ns1:t>RECORD: Block 1 stop/support needed __ ; Block 5 stop/support needed __.</ns1:t>
             </ns1:r>
           </ns1:p>
         </p:txBody>
@@ -5057,7 +5110,7 @@
     </p:spTree>
     <p:extLst>
       <p:ext uri="{BB962C8B-B14F-4D97-AF65-F5344CB8AC3E}">
-        <ns3:creationId val="1954053506"/>
+        <ns3:creationId val="1052799414"/>
       </p:ext>
     </p:extLst>
   </p:cSld>
@@ -5091,7 +5144,7 @@
           <p:cNvPr id="4" name="">
             <ns1:extLst>
               <ns1:ext uri="{FF2B5EF4-FFF2-40B4-BE49-F238E27FC236}">
-                <ns2:creationId id="{12D8806A-8CAB-4EC0-ACD7-D4A95B5EF674}"/>
+                <ns2:creationId id="{2D71B3B8-7806-41F0-805F-99BB147D937E}"/>
               </ns1:ext>
             </ns1:extLst>
           </p:cNvPr>
@@ -5157,7 +5210,7 @@
           <p:cNvPr id="2" name="">
             <ns1:extLst>
               <ns1:ext uri="{FF2B5EF4-FFF2-40B4-BE49-F238E27FC236}">
-                <ns2:creationId id="{C898A902-B651-4CD0-BD14-FBF7C16767D8}"/>
+                <ns2:creationId id="{CF33A0CB-7F65-4B6B-BE86-E5C8B662FE6D}"/>
               </ns1:ext>
             </ns1:extLst>
           </p:cNvPr>
@@ -5223,7 +5276,7 @@
           <p:cNvPr id="3" name="">
             <ns1:extLst>
               <ns1:ext uri="{FF2B5EF4-FFF2-40B4-BE49-F238E27FC236}">
-                <ns2:creationId id="{68445173-415D-4DF3-91AC-E08EA15BB30F}"/>
+                <ns2:creationId id="{9C2A39AD-6A9E-4BE0-BF32-A75583206A72}"/>
               </ns1:ext>
             </ns1:extLst>
           </p:cNvPr>
@@ -5335,7 +5388,7 @@
                 <ns1:ea typeface="Helvetica Neue"/>
                 <ns1:cs typeface="Helvetica Neue"/>
               </ns1:rPr>
-              <ns1:t>NOTE: 3–5 + 2 + 12 + 5 =22–24, leaving6–8minutes. If discussion runs longer, reduce buffer rather than claiming work finished.</ns1:t>
+              <ns1:t>NOTE: 3–5 + 2 + 12 + 5 =22–24, leaving 6–8 minutes. If discussion runs longer, reduce buffer rather than claiming work finished.</ns1:t>
             </ns1:r>
           </ns1:p>
         </p:txBody>
@@ -5343,7 +5396,7 @@
     </p:spTree>
     <p:extLst>
       <p:ext uri="{BB962C8B-B14F-4D97-AF65-F5344CB8AC3E}">
-        <ns3:creationId val="939860472"/>
+        <ns3:creationId val="434774029"/>
       </p:ext>
     </p:extLst>
   </p:cSld>
@@ -5377,7 +5430,7 @@
           <p:cNvPr id="4" name="">
             <ns1:extLst>
               <ns1:ext uri="{FF2B5EF4-FFF2-40B4-BE49-F238E27FC236}">
-                <ns2:creationId id="{5C503928-CBDD-444C-9B4A-BA510CCB95F4}"/>
+                <ns2:creationId id="{0D8D2DE5-FBA9-4C3F-8602-94B3BF3D4E7B}"/>
               </ns1:ext>
             </ns1:extLst>
           </p:cNvPr>
@@ -5443,7 +5496,7 @@
           <p:cNvPr id="2" name="">
             <ns1:extLst>
               <ns1:ext uri="{FF2B5EF4-FFF2-40B4-BE49-F238E27FC236}">
-                <ns2:creationId id="{4406D686-F89A-4700-90C9-EC29FE7E7D11}"/>
+                <ns2:creationId id="{ED8A0811-DF14-48F4-9DC1-86324F1BD92B}"/>
               </ns1:ext>
             </ns1:extLst>
           </p:cNvPr>
@@ -5509,7 +5562,7 @@
           <p:cNvPr id="3" name="">
             <ns1:extLst>
               <ns1:ext uri="{FF2B5EF4-FFF2-40B4-BE49-F238E27FC236}">
-                <ns2:creationId id="{B029B579-DF2F-422D-8258-7318F9054554}"/>
+                <ns2:creationId id="{AB969B2B-41DD-4396-8242-1FD5C20DC598}"/>
               </ns1:ext>
             </ns1:extLst>
           </p:cNvPr>
@@ -5601,7 +5654,7 @@
     </p:spTree>
     <p:extLst>
       <p:ext uri="{BB962C8B-B14F-4D97-AF65-F5344CB8AC3E}">
-        <ns3:creationId val="815949101"/>
+        <ns3:creationId val="1446806983"/>
       </p:ext>
     </p:extLst>
   </p:cSld>
@@ -5635,7 +5688,7 @@
           <p:cNvPr id="4" name="">
             <ns1:extLst>
               <ns1:ext uri="{FF2B5EF4-FFF2-40B4-BE49-F238E27FC236}">
-                <ns2:creationId id="{11BF5614-C98D-44D5-80E3-DDCD28D72FBC}"/>
+                <ns2:creationId id="{602ACB37-D0EC-4A84-8E19-DDC926B6D0A5}"/>
               </ns1:ext>
             </ns1:extLst>
           </p:cNvPr>
@@ -5701,7 +5754,7 @@
           <p:cNvPr id="2" name="">
             <ns1:extLst>
               <ns1:ext uri="{FF2B5EF4-FFF2-40B4-BE49-F238E27FC236}">
-                <ns2:creationId id="{1E35585A-1408-42EF-AD18-57CE9710E30B}"/>
+                <ns2:creationId id="{11F0BF39-C458-43B5-A10C-5DB5A6E14A89}"/>
               </ns1:ext>
             </ns1:extLst>
           </p:cNvPr>
@@ -5767,7 +5820,7 @@
           <p:cNvPr id="3" name="">
             <ns1:extLst>
               <ns1:ext uri="{FF2B5EF4-FFF2-40B4-BE49-F238E27FC236}">
-                <ns2:creationId id="{8FC698DA-A8F6-4F3C-8EB5-3DDA8AC2B32A}"/>
+                <ns2:creationId id="{43529470-B70E-4E35-85E3-5CA846FB5571}"/>
               </ns1:ext>
             </ns1:extLst>
           </p:cNvPr>
@@ -5879,7 +5932,7 @@
                 <ns1:ea typeface="Helvetica Neue"/>
                 <ns1:cs typeface="Helvetica Neue"/>
               </ns1:rPr>
-              <ns1:t>ASSESS: Understanding, not spelling, handwriting, accent, speed, or decorative work. Access support alone never reduces a level. Insufficient evidence is separate from level1; confirm IE and overall-score handling with Pat.</ns1:t>
+              <ns1:t>ASSESS: Understanding, not spelling, handwriting, accent, speed, or decorative work. Access support alone never reduces a level. Insufficient evidence is separate from level 1; confirm IE and overall-score handling with Pat.</ns1:t>
             </ns1:r>
           </ns1:p>
         </p:txBody>
@@ -5887,7 +5940,7 @@
     </p:spTree>
     <p:extLst>
       <p:ext uri="{BB962C8B-B14F-4D97-AF65-F5344CB8AC3E}">
-        <ns3:creationId val="868116085"/>
+        <ns3:creationId val="1106482971"/>
       </p:ext>
     </p:extLst>
   </p:cSld>
@@ -5921,7 +5974,7 @@
           <p:cNvPr id="4" name="">
             <ns1:extLst>
               <ns1:ext uri="{FF2B5EF4-FFF2-40B4-BE49-F238E27FC236}">
-                <ns2:creationId id="{3DD2DA97-07B9-4822-8692-FE5B6D06AC22}"/>
+                <ns2:creationId id="{DF36E27F-94CE-4C18-A2C9-9800CF9DDA31}"/>
               </ns1:ext>
             </ns1:extLst>
           </p:cNvPr>
@@ -5987,7 +6040,7 @@
           <p:cNvPr id="2" name="">
             <ns1:extLst>
               <ns1:ext uri="{FF2B5EF4-FFF2-40B4-BE49-F238E27FC236}">
-                <ns2:creationId id="{7C183440-0C86-4174-A66D-97DCE3EEFDCD}"/>
+                <ns2:creationId id="{36A54677-A0CC-4794-B222-E7B9B8041D0E}"/>
               </ns1:ext>
             </ns1:extLst>
           </p:cNvPr>
@@ -6053,7 +6106,7 @@
           <p:cNvPr id="3" name="">
             <ns1:extLst>
               <ns1:ext uri="{FF2B5EF4-FFF2-40B4-BE49-F238E27FC236}">
-                <ns2:creationId id="{CEA72448-4DC6-409E-8ED0-3CF8450400E8}"/>
+                <ns2:creationId id="{5E296A78-BD7B-4202-8BD7-9BF3072B11A3}"/>
               </ns1:ext>
             </ns1:extLst>
           </p:cNvPr>
@@ -6173,7 +6226,7 @@
     </p:spTree>
     <p:extLst>
       <p:ext uri="{BB962C8B-B14F-4D97-AF65-F5344CB8AC3E}">
-        <ns3:creationId val="223788572"/>
+        <ns3:creationId val="2055390681"/>
       </p:ext>
     </p:extLst>
   </p:cSld>
@@ -6207,7 +6260,7 @@
           <p:cNvPr id="4" name="">
             <ns1:extLst>
               <ns1:ext uri="{FF2B5EF4-FFF2-40B4-BE49-F238E27FC236}">
-                <ns2:creationId id="{F4A1F5F9-B39E-4A1C-9977-79CAE752DA91}"/>
+                <ns2:creationId id="{4074DDF0-EB75-4E40-8189-F19405F45F81}"/>
               </ns1:ext>
             </ns1:extLst>
           </p:cNvPr>
@@ -6273,7 +6326,7 @@
           <p:cNvPr id="2" name="">
             <ns1:extLst>
               <ns1:ext uri="{FF2B5EF4-FFF2-40B4-BE49-F238E27FC236}">
-                <ns2:creationId id="{C0214086-72B7-41DC-B6DB-BF3635EEDA73}"/>
+                <ns2:creationId id="{72AC47B6-ADFD-40C1-9D26-950BCAD01CA0}"/>
               </ns1:ext>
             </ns1:extLst>
           </p:cNvPr>
@@ -6339,7 +6392,7 @@
           <p:cNvPr id="3" name="">
             <ns1:extLst>
               <ns1:ext uri="{FF2B5EF4-FFF2-40B4-BE49-F238E27FC236}">
-                <ns2:creationId id="{D7001BE1-66E7-4066-9682-70305FDB9808}"/>
+                <ns2:creationId id="{CDF7D892-3F8F-44E5-9EE1-6B5874D02609}"/>
               </ns1:ext>
             </ns1:extLst>
           </p:cNvPr>
@@ -6423,7 +6476,7 @@
                 <ns1:ea typeface="Helvetica Neue"/>
                 <ns1:cs typeface="Helvetica Neue"/>
               </ns1:rPr>
-              <ns1:t>DO: Start2min timer. If stuck, offer a familiar business category such as a cafe, shoe shop, or digital-book service.</ns1:t>
+              <ns1:t>DO: Start a 2-minute timer. If stuck, offer a familiar business category such as a cafe, shoe shop, or digital-book service.</ns1:t>
             </ns1:r>
           </ns1:p>
           <ns1:p>
@@ -6459,7 +6512,7 @@
     </p:spTree>
     <p:extLst>
       <p:ext uri="{BB962C8B-B14F-4D97-AF65-F5344CB8AC3E}">
-        <ns3:creationId val="2136526210"/>
+        <ns3:creationId val="593249840"/>
       </p:ext>
     </p:extLst>
   </p:cSld>
@@ -6493,7 +6546,7 @@
           <p:cNvPr id="4" name="">
             <ns1:extLst>
               <ns1:ext uri="{FF2B5EF4-FFF2-40B4-BE49-F238E27FC236}">
-                <ns2:creationId id="{B80A2D99-B9A7-426F-BC78-63BEE0A53E5D}"/>
+                <ns2:creationId id="{70B7F621-4805-43B5-8D2A-96935E08C84A}"/>
               </ns1:ext>
             </ns1:extLst>
           </p:cNvPr>
@@ -6559,7 +6612,7 @@
           <p:cNvPr id="2" name="">
             <ns1:extLst>
               <ns1:ext uri="{FF2B5EF4-FFF2-40B4-BE49-F238E27FC236}">
-                <ns2:creationId id="{32E730AA-3F7A-4662-9C92-163897914874}"/>
+                <ns2:creationId id="{4440CC2F-7CEA-45D9-B512-FA26A00BB972}"/>
               </ns1:ext>
             </ns1:extLst>
           </p:cNvPr>
@@ -6625,7 +6678,7 @@
           <p:cNvPr id="3" name="">
             <ns1:extLst>
               <ns1:ext uri="{FF2B5EF4-FFF2-40B4-BE49-F238E27FC236}">
-                <ns2:creationId id="{98CAEFF4-B730-4727-BD8D-A2313B8C284C}"/>
+                <ns2:creationId id="{D1C90217-369A-42C8-9180-C95E8B53006B}"/>
               </ns1:ext>
             </ns1:extLst>
           </p:cNvPr>
@@ -6709,7 +6762,7 @@
                 <ns1:ea typeface="Helvetica Neue"/>
                 <ns1:cs typeface="Helvetica Neue"/>
               </ns1:rPr>
-              <ns1:t>DO: Read the category cue, start3min, stand at a deliberate scan point.</ns1:t>
+              <ns1:t>DO: Start a 3-minute timer. Each partner explains an impact. Record the shared answer and switch roles for the next category.</ns1:t>
             </ns1:r>
           </ns1:p>
           <ns1:p>
@@ -6737,7 +6790,7 @@
                 <ns1:ea typeface="Helvetica Neue"/>
                 <ns1:cs typeface="Helvetica Neue"/>
               </ns1:rPr>
-              <ns1:t>LISTEN FOR: External factor, category fit, effect on this business or target market, because reasoning.</ns1:t>
+              <ns1:t>LOOK FOR: External factor, correct category, business impact, and a because explanation.</ns1:t>
             </ns1:r>
           </ns1:p>
           <ns1:p>
@@ -6765,7 +6818,7 @@
                 <ns1:ea typeface="Helvetica Neue"/>
                 <ns1:cs typeface="Helvetica Neue"/>
               </ns1:rPr>
-              <ns1:t>IF WEAK: Ask “What changed outside the business? What happens to costs, customers, or access?” Model a question, not their answer.</ns1:t>
+              <ns1:t>SUPPORT: Ask what changed outside the business and what happens to costs, customers, or access.</ns1:t>
             </ns1:r>
           </ns1:p>
           <ns1:p>
@@ -6793,7 +6846,7 @@
                 <ns1:ea typeface="Helvetica Neue"/>
                 <ns1:cs typeface="Helvetica Neue"/>
               </ns1:rPr>
-              <ns1:t>IF STRONG: Ask which impact matters most and why.</ns1:t>
+              <ns1:t>EXTEND: Ask which impact matters most and why.</ns1:t>
             </ns1:r>
           </ns1:p>
           <ns1:p>
@@ -6821,7 +6874,7 @@
                 <ns1:ea typeface="Helvetica Neue"/>
                 <ns1:cs typeface="Helvetica Neue"/>
               </ns1:rPr>
-              <ns1:t>CHECK: Do not classify the business’s own ad, discount, or new app decision as the external factor.</ns1:t>
+              <ns1:t>CHECK: An ad, discount, or app chosen by the business is its internal response, not the external factor.</ns1:t>
             </ns1:r>
           </ns1:p>
         </p:txBody>
@@ -6829,7 +6882,7 @@
     </p:spTree>
     <p:extLst>
       <p:ext uri="{BB962C8B-B14F-4D97-AF65-F5344CB8AC3E}">
-        <ns3:creationId val="617399469"/>
+        <ns3:creationId val="1086263602"/>
       </p:ext>
     </p:extLst>
   </p:cSld>
@@ -6863,7 +6916,7 @@
           <p:cNvPr id="4" name="">
             <ns1:extLst>
               <ns1:ext uri="{FF2B5EF4-FFF2-40B4-BE49-F238E27FC236}">
-                <ns2:creationId id="{55A99DC6-057C-4394-B227-A1FB40547102}"/>
+                <ns2:creationId id="{8C68FBBF-FFF1-44EC-BCE0-CABDA771393B}"/>
               </ns1:ext>
             </ns1:extLst>
           </p:cNvPr>
@@ -6929,7 +6982,7 @@
           <p:cNvPr id="2" name="">
             <ns1:extLst>
               <ns1:ext uri="{FF2B5EF4-FFF2-40B4-BE49-F238E27FC236}">
-                <ns2:creationId id="{8FB69E48-6D01-41AD-BC83-FDD95C75BBBE}"/>
+                <ns2:creationId id="{F7B7E547-6C71-4929-BC52-16D78E5B70F4}"/>
               </ns1:ext>
             </ns1:extLst>
           </p:cNvPr>
@@ -6995,7 +7048,7 @@
           <p:cNvPr id="3" name="">
             <ns1:extLst>
               <ns1:ext uri="{FF2B5EF4-FFF2-40B4-BE49-F238E27FC236}">
-                <ns2:creationId id="{0B93DBE3-4A57-4A8C-A2EE-6E5E7AC4D211}"/>
+                <ns2:creationId id="{F9A8EF45-1AB3-4523-A53A-12431095C954}"/>
               </ns1:ext>
             </ns1:extLst>
           </p:cNvPr>
@@ -7079,7 +7132,7 @@
                 <ns1:ea typeface="Helvetica Neue"/>
                 <ns1:cs typeface="Helvetica Neue"/>
               </ns1:rPr>
-              <ns1:t>DO: Read the category cue, start3min, stand at a deliberate scan point.</ns1:t>
+              <ns1:t>DO: Start a 3-minute timer. Each partner explains an impact. Record the shared answer and switch roles for the next category.</ns1:t>
             </ns1:r>
           </ns1:p>
           <ns1:p>
@@ -7107,7 +7160,7 @@
                 <ns1:ea typeface="Helvetica Neue"/>
                 <ns1:cs typeface="Helvetica Neue"/>
               </ns1:rPr>
-              <ns1:t>LISTEN FOR: External factor, category fit, effect on this business or target market, because reasoning.</ns1:t>
+              <ns1:t>LOOK FOR: External factor, correct category, business impact, and a because explanation.</ns1:t>
             </ns1:r>
           </ns1:p>
           <ns1:p>
@@ -7135,7 +7188,7 @@
                 <ns1:ea typeface="Helvetica Neue"/>
                 <ns1:cs typeface="Helvetica Neue"/>
               </ns1:rPr>
-              <ns1:t>IF WEAK: Ask “What changed outside the business? What happens to costs, customers, or access?” Model a question, not their answer.</ns1:t>
+              <ns1:t>SUPPORT: Ask what changed outside the business and what happens to costs, customers, or access.</ns1:t>
             </ns1:r>
           </ns1:p>
           <ns1:p>
@@ -7163,7 +7216,7 @@
                 <ns1:ea typeface="Helvetica Neue"/>
                 <ns1:cs typeface="Helvetica Neue"/>
               </ns1:rPr>
-              <ns1:t>IF STRONG: Ask which impact matters most and why.</ns1:t>
+              <ns1:t>EXTEND: Ask which impact matters most and why.</ns1:t>
             </ns1:r>
           </ns1:p>
           <ns1:p>
@@ -7191,7 +7244,7 @@
                 <ns1:ea typeface="Helvetica Neue"/>
                 <ns1:cs typeface="Helvetica Neue"/>
               </ns1:rPr>
-              <ns1:t>CHECK: Do not classify the business’s own ad, discount, or new app decision as the external factor.</ns1:t>
+              <ns1:t>CHECK: An ad, discount, or app chosen by the business is its internal response, not the external factor.</ns1:t>
             </ns1:r>
           </ns1:p>
         </p:txBody>
@@ -7199,7 +7252,7 @@
     </p:spTree>
     <p:extLst>
       <p:ext uri="{BB962C8B-B14F-4D97-AF65-F5344CB8AC3E}">
-        <ns3:creationId val="85885885"/>
+        <ns3:creationId val="1450290026"/>
       </p:ext>
     </p:extLst>
   </p:cSld>
@@ -7233,7 +7286,7 @@
           <p:cNvPr id="4" name="">
             <ns1:extLst>
               <ns1:ext uri="{FF2B5EF4-FFF2-40B4-BE49-F238E27FC236}">
-                <ns2:creationId id="{58DC4845-349B-4FDA-A872-45337919A427}"/>
+                <ns2:creationId id="{DBF82DC0-916E-4EEE-98EB-56D7C4BB3CD5}"/>
               </ns1:ext>
             </ns1:extLst>
           </p:cNvPr>
@@ -7299,7 +7352,7 @@
           <p:cNvPr id="2" name="">
             <ns1:extLst>
               <ns1:ext uri="{FF2B5EF4-FFF2-40B4-BE49-F238E27FC236}">
-                <ns2:creationId id="{931B58D6-A332-4305-9F73-4F405819873D}"/>
+                <ns2:creationId id="{836DDBB3-A62B-4272-A534-822CC4ADF27D}"/>
               </ns1:ext>
             </ns1:extLst>
           </p:cNvPr>
@@ -7365,7 +7418,7 @@
           <p:cNvPr id="3" name="">
             <ns1:extLst>
               <ns1:ext uri="{FF2B5EF4-FFF2-40B4-BE49-F238E27FC236}">
-                <ns2:creationId id="{A43D4E55-FB9D-4286-8857-9E5A51C8E378}"/>
+                <ns2:creationId id="{527C5F3F-996B-4EDE-9EC9-633EB3BF026A}"/>
               </ns1:ext>
             </ns1:extLst>
           </p:cNvPr>
@@ -7449,7 +7502,7 @@
                 <ns1:ea typeface="Helvetica Neue"/>
                 <ns1:cs typeface="Helvetica Neue"/>
               </ns1:rPr>
-              <ns1:t>DO: Read the category cue, start3min, stand at a deliberate scan point.</ns1:t>
+              <ns1:t>DO: Start a 3-minute timer. Each partner explains an impact. Record the shared answer and switch roles for the next category.</ns1:t>
             </ns1:r>
           </ns1:p>
           <ns1:p>
@@ -7477,7 +7530,7 @@
                 <ns1:ea typeface="Helvetica Neue"/>
                 <ns1:cs typeface="Helvetica Neue"/>
               </ns1:rPr>
-              <ns1:t>LISTEN FOR: External factor, category fit, effect on this business or target market, because reasoning.</ns1:t>
+              <ns1:t>LOOK FOR: External factor, correct category, business impact, and a because explanation.</ns1:t>
             </ns1:r>
           </ns1:p>
           <ns1:p>
@@ -7505,7 +7558,7 @@
                 <ns1:ea typeface="Helvetica Neue"/>
                 <ns1:cs typeface="Helvetica Neue"/>
               </ns1:rPr>
-              <ns1:t>IF WEAK: Ask “What changed outside the business? What happens to costs, customers, or access?” Model a question, not their answer.</ns1:t>
+              <ns1:t>SUPPORT: Ask what changed outside the business and what happens to costs, customers, or access.</ns1:t>
             </ns1:r>
           </ns1:p>
           <ns1:p>
@@ -7533,7 +7586,7 @@
                 <ns1:ea typeface="Helvetica Neue"/>
                 <ns1:cs typeface="Helvetica Neue"/>
               </ns1:rPr>
-              <ns1:t>IF STRONG: Ask which impact matters most and why.</ns1:t>
+              <ns1:t>EXTEND: Ask which impact matters most and why.</ns1:t>
             </ns1:r>
           </ns1:p>
           <ns1:p>
@@ -7561,7 +7614,7 @@
                 <ns1:ea typeface="Helvetica Neue"/>
                 <ns1:cs typeface="Helvetica Neue"/>
               </ns1:rPr>
-              <ns1:t>CHECK: Do not classify the business’s own ad, discount, or new app decision as the external factor.</ns1:t>
+              <ns1:t>CHECK: An ad, discount, or app chosen by the business is its internal response, not the external factor.</ns1:t>
             </ns1:r>
           </ns1:p>
         </p:txBody>
@@ -7569,7 +7622,7 @@
     </p:spTree>
     <p:extLst>
       <p:ext uri="{BB962C8B-B14F-4D97-AF65-F5344CB8AC3E}">
-        <ns3:creationId val="1154863305"/>
+        <ns3:creationId val="176160057"/>
       </p:ext>
     </p:extLst>
   </p:cSld>

</xml_diff>

<commit_message>
Apply Viber targeted review correction for PEST student success criteria
</commit_message>
<xml_diff>
--- a/second-placement/planning/chapter-2-marketing-plan/2026-10-14-PEST-Piter-Run-Guide-v1.pptx
+++ b/second-placement/planning/chapter-2-marketing-plan/2026-10-14-PEST-Piter-Run-Guide-v1.pptx
@@ -2,24 +2,24 @@
 <file path=ppt/presentation.xml><?xml version="1.0" encoding="utf-8"?>
 <p:presentation xmlns:p="http://schemas.openxmlformats.org/presentationml/2006/main">
   <p:sldMasterIdLst>
-    <p:sldMasterId xmlns:r="http://schemas.openxmlformats.org/officeDocument/2006/relationships" id="2147483648" r:id="Raf7ac0934b0a4214"/>
+    <p:sldMasterId xmlns:r="http://schemas.openxmlformats.org/officeDocument/2006/relationships" id="2147483648" r:id="Re5772c9899544ca7"/>
   </p:sldMasterIdLst>
   <p:notesMasterIdLst>
-    <p:notesMasterId xmlns:r="http://schemas.openxmlformats.org/officeDocument/2006/relationships" r:id="R111d23d360ce4bcb"/>
+    <p:notesMasterId xmlns:r="http://schemas.openxmlformats.org/officeDocument/2006/relationships" r:id="R16ad1f780b0e4977"/>
   </p:notesMasterIdLst>
   <p:sldIdLst>
-    <p:sldId xmlns:r="http://schemas.openxmlformats.org/officeDocument/2006/relationships" id="256" r:id="R0a5ce51e492940af"/>
-    <p:sldId xmlns:r="http://schemas.openxmlformats.org/officeDocument/2006/relationships" id="257" r:id="R518dc50481b944ee"/>
-    <p:sldId xmlns:r="http://schemas.openxmlformats.org/officeDocument/2006/relationships" id="258" r:id="R171fca5b73c84fb7"/>
-    <p:sldId xmlns:r="http://schemas.openxmlformats.org/officeDocument/2006/relationships" id="259" r:id="R8672a1feb3bb4619"/>
-    <p:sldId xmlns:r="http://schemas.openxmlformats.org/officeDocument/2006/relationships" id="260" r:id="R6ab2166ad6984b88"/>
-    <p:sldId xmlns:r="http://schemas.openxmlformats.org/officeDocument/2006/relationships" id="261" r:id="Ra971b682859c4059"/>
-    <p:sldId xmlns:r="http://schemas.openxmlformats.org/officeDocument/2006/relationships" id="262" r:id="R7780be5539f145ff"/>
-    <p:sldId xmlns:r="http://schemas.openxmlformats.org/officeDocument/2006/relationships" id="263" r:id="Rdf29ce8ea6f7465a"/>
-    <p:sldId xmlns:r="http://schemas.openxmlformats.org/officeDocument/2006/relationships" id="264" r:id="Re2b8ac2c87484bc1"/>
-    <p:sldId xmlns:r="http://schemas.openxmlformats.org/officeDocument/2006/relationships" id="265" r:id="R152d58a92ff74013"/>
-    <p:sldId xmlns:r="http://schemas.openxmlformats.org/officeDocument/2006/relationships" id="266" r:id="R71cb09afc28b43e9"/>
-    <p:sldId xmlns:r="http://schemas.openxmlformats.org/officeDocument/2006/relationships" id="267" r:id="Rfd034a69f9634f48"/>
+    <p:sldId xmlns:r="http://schemas.openxmlformats.org/officeDocument/2006/relationships" id="256" r:id="R8d14956b5a754668"/>
+    <p:sldId xmlns:r="http://schemas.openxmlformats.org/officeDocument/2006/relationships" id="257" r:id="R379b2aae73d94117"/>
+    <p:sldId xmlns:r="http://schemas.openxmlformats.org/officeDocument/2006/relationships" id="258" r:id="Rb33d2d17c6704baf"/>
+    <p:sldId xmlns:r="http://schemas.openxmlformats.org/officeDocument/2006/relationships" id="259" r:id="Rcffc66d57fe24504"/>
+    <p:sldId xmlns:r="http://schemas.openxmlformats.org/officeDocument/2006/relationships" id="260" r:id="R9c1d6ced86984ae6"/>
+    <p:sldId xmlns:r="http://schemas.openxmlformats.org/officeDocument/2006/relationships" id="261" r:id="R665db1cab3a14c65"/>
+    <p:sldId xmlns:r="http://schemas.openxmlformats.org/officeDocument/2006/relationships" id="262" r:id="R85c8fb488a3b49b6"/>
+    <p:sldId xmlns:r="http://schemas.openxmlformats.org/officeDocument/2006/relationships" id="263" r:id="Rdb392b1087364fcf"/>
+    <p:sldId xmlns:r="http://schemas.openxmlformats.org/officeDocument/2006/relationships" id="264" r:id="Rdc1165d42c5e4b54"/>
+    <p:sldId xmlns:r="http://schemas.openxmlformats.org/officeDocument/2006/relationships" id="265" r:id="R3d96dd84f65d4fa2"/>
+    <p:sldId xmlns:r="http://schemas.openxmlformats.org/officeDocument/2006/relationships" id="266" r:id="R55332fb44e4d4e46"/>
+    <p:sldId xmlns:r="http://schemas.openxmlformats.org/officeDocument/2006/relationships" id="267" r:id="R688df90c8ad84e70"/>
   </p:sldIdLst>
   <p:sldSz cx="12192000" cy="6858000"/>
   <p:notesSz cx="6858000" cy="9144000"/>
@@ -938,7 +938,7 @@
           <a:lstStyle xmlns:a="http://schemas.openxmlformats.org/drawingml/2006/main"/>
           <a:p xmlns:a="http://schemas.openxmlformats.org/drawingml/2006/main">
             <a:r>
-              <a:t>SAY: “A 3 shows complete, accurate application. A 4 explains a deeper decision and why it makes sense. More words alone do not earn a 4.”</a:t>
+              <a:t>IF PAT APPROVES THE NUMERICAL RUBRIC: SAY: “A 3 shows complete, accurate application. A 4 explains a deeper decision and why it makes sense. More words alone do not earn a 4.”</a:t>
             </a:r>
           </a:p>
           <a:p xmlns:a="http://schemas.openxmlformats.org/drawingml/2006/main">
@@ -1023,7 +1023,7 @@
           <a:lstStyle xmlns:a="http://schemas.openxmlformats.org/drawingml/2006/main"/>
           <a:p xmlns:a="http://schemas.openxmlformats.org/drawingml/2006/main">
             <a:r>
-              <a:t>SAY: “Use business terms and explain because. A list of words does not yet show why a business is affected.”</a:t>
+              <a:t>IF PAT APPROVES THE NUMERICAL RUBRIC: SAY: “Use business terms and explain because. A list of words does not yet show why a business is affected.”</a:t>
             </a:r>
           </a:p>
           <a:p xmlns:a="http://schemas.openxmlformats.org/drawingml/2006/main">
@@ -1600,7 +1600,7 @@
           <p:cNvPr id="3" name="Title">
             <a:extLst xmlns:a="http://schemas.openxmlformats.org/drawingml/2006/main">
               <a:ext uri="{FF2B5EF4-FFF2-40B4-BE49-F238E27FC236}">
-                <a16:creationId xmlns:a16="http://schemas.microsoft.com/office/drawing/2014/main" id="{E91005FD-660F-4C9A-B85C-DB0B9ABBC9D7}"/>
+                <a16:creationId xmlns:a16="http://schemas.microsoft.com/office/drawing/2014/main" id="{C8B01F7B-D26D-48F4-B6F6-D6B93DCB8ADA}"/>
               </a:ext>
             </a:extLst>
           </p:cNvPr>
@@ -1757,7 +1757,7 @@
           <p:cNvPr id="2" name="Subtitle">
             <a:extLst xmlns:a="http://schemas.openxmlformats.org/drawingml/2006/main">
               <a:ext uri="{FF2B5EF4-FFF2-40B4-BE49-F238E27FC236}">
-                <a16:creationId xmlns:a16="http://schemas.microsoft.com/office/drawing/2014/main" id="{C6F45A8E-87FA-49F8-B35E-A8602EB6A47B}"/>
+                <a16:creationId xmlns:a16="http://schemas.microsoft.com/office/drawing/2014/main" id="{B7010CDD-4F6B-4A63-960E-D37078F68563}"/>
               </a:ext>
             </a:extLst>
           </p:cNvPr>
@@ -1931,7 +1931,7 @@
           <p:cNvPr id="2" name="Section title">
             <a:extLst xmlns:a="http://schemas.openxmlformats.org/drawingml/2006/main">
               <a:ext uri="{FF2B5EF4-FFF2-40B4-BE49-F238E27FC236}">
-                <a16:creationId xmlns:a16="http://schemas.microsoft.com/office/drawing/2014/main" id="{72840F05-BD43-43AA-85E7-1BCC7F630C66}"/>
+                <a16:creationId xmlns:a16="http://schemas.microsoft.com/office/drawing/2014/main" id="{1713FB83-9445-44D2-BE7B-4080FC498DD5}"/>
               </a:ext>
             </a:extLst>
           </p:cNvPr>
@@ -2105,7 +2105,7 @@
           <p:cNvPr id="3" name="Title">
             <a:extLst xmlns:a="http://schemas.openxmlformats.org/drawingml/2006/main">
               <a:ext uri="{FF2B5EF4-FFF2-40B4-BE49-F238E27FC236}">
-                <a16:creationId xmlns:a16="http://schemas.microsoft.com/office/drawing/2014/main" id="{32CCD2CE-E6E7-45BA-9434-8514BF88BF35}"/>
+                <a16:creationId xmlns:a16="http://schemas.microsoft.com/office/drawing/2014/main" id="{CF1C8351-9EA5-48CC-B40C-08D955873400}"/>
               </a:ext>
             </a:extLst>
           </p:cNvPr>
@@ -2262,7 +2262,7 @@
           <p:cNvPr id="2" name="Body">
             <a:extLst xmlns:a="http://schemas.openxmlformats.org/drawingml/2006/main">
               <a:ext uri="{FF2B5EF4-FFF2-40B4-BE49-F238E27FC236}">
-                <a16:creationId xmlns:a16="http://schemas.microsoft.com/office/drawing/2014/main" id="{A356F3DC-ECCB-42E2-BD0F-6F3EA5825850}"/>
+                <a16:creationId xmlns:a16="http://schemas.microsoft.com/office/drawing/2014/main" id="{D40239B2-9887-4232-B258-A0DA6BA28E00}"/>
               </a:ext>
             </a:extLst>
           </p:cNvPr>
@@ -2436,7 +2436,7 @@
           <p:cNvPr id="4" name="Title">
             <a:extLst xmlns:a="http://schemas.openxmlformats.org/drawingml/2006/main">
               <a:ext uri="{FF2B5EF4-FFF2-40B4-BE49-F238E27FC236}">
-                <a16:creationId xmlns:a16="http://schemas.microsoft.com/office/drawing/2014/main" id="{6184D157-5195-431C-AFE1-9741D8F8A333}"/>
+                <a16:creationId xmlns:a16="http://schemas.microsoft.com/office/drawing/2014/main" id="{AA9C183F-0746-4BBB-8C98-EB089381BDD8}"/>
               </a:ext>
             </a:extLst>
           </p:cNvPr>
@@ -2593,7 +2593,7 @@
           <p:cNvPr id="2" name="Left column">
             <a:extLst xmlns:a="http://schemas.openxmlformats.org/drawingml/2006/main">
               <a:ext uri="{FF2B5EF4-FFF2-40B4-BE49-F238E27FC236}">
-                <a16:creationId xmlns:a16="http://schemas.microsoft.com/office/drawing/2014/main" id="{B509F7C7-7C64-4911-97A4-84AD962CECED}"/>
+                <a16:creationId xmlns:a16="http://schemas.microsoft.com/office/drawing/2014/main" id="{E8A6D10F-349B-4098-9E61-4B852092C815}"/>
               </a:ext>
             </a:extLst>
           </p:cNvPr>
@@ -2750,7 +2750,7 @@
           <p:cNvPr id="3" name="Right column">
             <a:extLst xmlns:a="http://schemas.openxmlformats.org/drawingml/2006/main">
               <a:ext uri="{FF2B5EF4-FFF2-40B4-BE49-F238E27FC236}">
-                <a16:creationId xmlns:a16="http://schemas.microsoft.com/office/drawing/2014/main" id="{4F9964BA-A02F-4479-963A-4888205BB33F}"/>
+                <a16:creationId xmlns:a16="http://schemas.microsoft.com/office/drawing/2014/main" id="{634D8424-DFDE-453A-8709-4B6479042425}"/>
               </a:ext>
             </a:extLst>
           </p:cNvPr>
@@ -2924,7 +2924,7 @@
           <p:cNvPr id="3" name="Title">
             <a:extLst xmlns:a="http://schemas.openxmlformats.org/drawingml/2006/main">
               <a:ext uri="{FF2B5EF4-FFF2-40B4-BE49-F238E27FC236}">
-                <a16:creationId xmlns:a16="http://schemas.microsoft.com/office/drawing/2014/main" id="{0E2A90D3-BDBF-4454-9B94-488F882E771D}"/>
+                <a16:creationId xmlns:a16="http://schemas.microsoft.com/office/drawing/2014/main" id="{CF8FD85B-2617-48C5-9E03-F09CC3BC984A}"/>
               </a:ext>
             </a:extLst>
           </p:cNvPr>
@@ -3081,7 +3081,7 @@
           <p:cNvPr id="2" name="Left column">
             <a:extLst xmlns:a="http://schemas.openxmlformats.org/drawingml/2006/main">
               <a:ext uri="{FF2B5EF4-FFF2-40B4-BE49-F238E27FC236}">
-                <a16:creationId xmlns:a16="http://schemas.microsoft.com/office/drawing/2014/main" id="{DF36E99E-F4B6-4F2D-BE96-1497A1D29464}"/>
+                <a16:creationId xmlns:a16="http://schemas.microsoft.com/office/drawing/2014/main" id="{A7C61D7F-6C3D-4AB6-BD59-EB8DD6D996E1}"/>
               </a:ext>
             </a:extLst>
           </p:cNvPr>
@@ -3276,12 +3276,12 @@
   </p:cSld>
   <p:clrMap bg1="lt1" tx1="dk1" bg2="lt2" tx2="dk2" accent1="accent1" accent2="accent2" accent3="accent3" accent4="accent4" accent5="accent5" accent6="accent6" hlink="hlink" folHlink="folHlink"/>
   <p:sldLayoutIdLst>
-    <p:sldLayoutId xmlns:r="http://schemas.openxmlformats.org/officeDocument/2006/relationships" id="2147483649" r:id="Rc4ceb14e12bd4506"/>
-    <p:sldLayoutId xmlns:r="http://schemas.openxmlformats.org/officeDocument/2006/relationships" id="2147483650" r:id="Red82860eda9c4b27"/>
-    <p:sldLayoutId xmlns:r="http://schemas.openxmlformats.org/officeDocument/2006/relationships" id="2147483651" r:id="R8b2d54f67eab47fd"/>
-    <p:sldLayoutId xmlns:r="http://schemas.openxmlformats.org/officeDocument/2006/relationships" id="2147483652" r:id="R8172b3a8dd844a50"/>
-    <p:sldLayoutId xmlns:r="http://schemas.openxmlformats.org/officeDocument/2006/relationships" id="2147483653" r:id="R95f4d958e59b4e83"/>
-    <p:sldLayoutId xmlns:r="http://schemas.openxmlformats.org/officeDocument/2006/relationships" id="2147483654" r:id="Rb687d839e88647d7"/>
+    <p:sldLayoutId xmlns:r="http://schemas.openxmlformats.org/officeDocument/2006/relationships" id="2147483649" r:id="R72932ee1dad548db"/>
+    <p:sldLayoutId xmlns:r="http://schemas.openxmlformats.org/officeDocument/2006/relationships" id="2147483650" r:id="R3691a23045c44447"/>
+    <p:sldLayoutId xmlns:r="http://schemas.openxmlformats.org/officeDocument/2006/relationships" id="2147483651" r:id="R9b2d27cf7c0942a1"/>
+    <p:sldLayoutId xmlns:r="http://schemas.openxmlformats.org/officeDocument/2006/relationships" id="2147483652" r:id="Rd06f7ddd7c224017"/>
+    <p:sldLayoutId xmlns:r="http://schemas.openxmlformats.org/officeDocument/2006/relationships" id="2147483653" r:id="R66ee34e54a3243ee"/>
+    <p:sldLayoutId xmlns:r="http://schemas.openxmlformats.org/officeDocument/2006/relationships" id="2147483654" r:id="R57bbaf8c15514961"/>
   </p:sldLayoutIdLst>
   <p:txStyles>
     <p:titleStyle>
@@ -3832,7 +3832,7 @@
           <p:cNvPr id="4" name="">
             <ns1:extLst>
               <ns1:ext uri="{FF2B5EF4-FFF2-40B4-BE49-F238E27FC236}">
-                <ns2:creationId id="{D5F34E39-F88B-4864-BA3C-070D3A8896DD}"/>
+                <ns2:creationId id="{6FDC6401-04B0-4135-9D61-09227716CAC2}"/>
               </ns1:ext>
             </ns1:extLst>
           </p:cNvPr>
@@ -3898,7 +3898,7 @@
           <p:cNvPr id="2" name="">
             <ns1:extLst>
               <ns1:ext uri="{FF2B5EF4-FFF2-40B4-BE49-F238E27FC236}">
-                <ns2:creationId id="{64213D36-2E31-4203-BB5D-404E3928806C}"/>
+                <ns2:creationId id="{07E8D582-19A8-4110-87EB-1C6FA1A686E4}"/>
               </ns1:ext>
             </ns1:extLst>
           </p:cNvPr>
@@ -3964,7 +3964,7 @@
           <p:cNvPr id="3" name="">
             <ns1:extLst>
               <ns1:ext uri="{FF2B5EF4-FFF2-40B4-BE49-F238E27FC236}">
-                <ns2:creationId id="{D15BD7F2-AF2B-4FB8-BDF1-9E2688198F98}"/>
+                <ns2:creationId id="{2E8B83B4-0914-4620-B6F9-F7B281FA8503}"/>
               </ns1:ext>
             </ns1:extLst>
           </p:cNvPr>
@@ -4084,7 +4084,7 @@
     </p:spTree>
     <p:extLst>
       <p:ext uri="{BB962C8B-B14F-4D97-AF65-F5344CB8AC3E}">
-        <ns3:creationId val="1765780660"/>
+        <ns3:creationId val="2096561949"/>
       </p:ext>
     </p:extLst>
   </p:cSld>
@@ -4118,7 +4118,7 @@
           <p:cNvPr id="4" name="">
             <ns1:extLst>
               <ns1:ext uri="{FF2B5EF4-FFF2-40B4-BE49-F238E27FC236}">
-                <ns2:creationId id="{F347CB34-913A-46F9-A22F-4A86E2D51777}"/>
+                <ns2:creationId id="{85E1FA4C-C87E-48F2-A082-562F4F3E1845}"/>
               </ns1:ext>
             </ns1:extLst>
           </p:cNvPr>
@@ -4184,7 +4184,7 @@
           <p:cNvPr id="2" name="">
             <ns1:extLst>
               <ns1:ext uri="{FF2B5EF4-FFF2-40B4-BE49-F238E27FC236}">
-                <ns2:creationId id="{20B679BF-0C49-475B-B0CF-4B1C64F55CF7}"/>
+                <ns2:creationId id="{A5820873-B93D-4DDE-8D3D-56835B4329AD}"/>
               </ns1:ext>
             </ns1:extLst>
           </p:cNvPr>
@@ -4250,7 +4250,7 @@
           <p:cNvPr id="3" name="">
             <ns1:extLst>
               <ns1:ext uri="{FF2B5EF4-FFF2-40B4-BE49-F238E27FC236}">
-                <ns2:creationId id="{FC32B38C-8ABE-43F1-9786-758A062C0629}"/>
+                <ns2:creationId id="{8CC86DE8-E140-40BA-A27C-9457C9F67CB4}"/>
               </ns1:ext>
             </ns1:extLst>
           </p:cNvPr>
@@ -4454,7 +4454,7 @@
     </p:spTree>
     <p:extLst>
       <p:ext uri="{BB962C8B-B14F-4D97-AF65-F5344CB8AC3E}">
-        <ns3:creationId val="364950419"/>
+        <ns3:creationId val="1186554584"/>
       </p:ext>
     </p:extLst>
   </p:cSld>
@@ -4488,7 +4488,7 @@
           <p:cNvPr id="4" name="">
             <ns1:extLst>
               <ns1:ext uri="{FF2B5EF4-FFF2-40B4-BE49-F238E27FC236}">
-                <ns2:creationId id="{3253630C-45A7-4179-BFC9-84C8E9A24E11}"/>
+                <ns2:creationId id="{900B4599-2352-4B0A-8C77-96A481C1DB9B}"/>
               </ns1:ext>
             </ns1:extLst>
           </p:cNvPr>
@@ -4554,7 +4554,7 @@
           <p:cNvPr id="2" name="">
             <ns1:extLst>
               <ns1:ext uri="{FF2B5EF4-FFF2-40B4-BE49-F238E27FC236}">
-                <ns2:creationId id="{62291E7B-F9B1-44E2-8ED1-28CE7D57ACFF}"/>
+                <ns2:creationId id="{6E77D3E6-08FD-4C33-817C-8993C9BD6995}"/>
               </ns1:ext>
             </ns1:extLst>
           </p:cNvPr>
@@ -4620,7 +4620,7 @@
           <p:cNvPr id="3" name="">
             <ns1:extLst>
               <ns1:ext uri="{FF2B5EF4-FFF2-40B4-BE49-F238E27FC236}">
-                <ns2:creationId id="{3E8D7BD2-179B-42DB-853B-FA6C6E2BD912}"/>
+                <ns2:creationId id="{FEEBF681-1703-4F78-9476-5C025919F193}"/>
               </ns1:ext>
             </ns1:extLst>
           </p:cNvPr>
@@ -4796,7 +4796,7 @@
     </p:spTree>
     <p:extLst>
       <p:ext uri="{BB962C8B-B14F-4D97-AF65-F5344CB8AC3E}">
-        <ns3:creationId val="1887358174"/>
+        <ns3:creationId val="1785978793"/>
       </p:ext>
     </p:extLst>
   </p:cSld>
@@ -4830,7 +4830,7 @@
           <p:cNvPr id="4" name="">
             <ns1:extLst>
               <ns1:ext uri="{FF2B5EF4-FFF2-40B4-BE49-F238E27FC236}">
-                <ns2:creationId id="{6E1119B4-4A34-422C-AC77-DD4200D77976}"/>
+                <ns2:creationId id="{DC778C3F-B050-4130-812B-1C7F4B8F9570}"/>
               </ns1:ext>
             </ns1:extLst>
           </p:cNvPr>
@@ -4896,7 +4896,7 @@
           <p:cNvPr id="2" name="">
             <ns1:extLst>
               <ns1:ext uri="{FF2B5EF4-FFF2-40B4-BE49-F238E27FC236}">
-                <ns2:creationId id="{1FA8F061-18C0-4950-B889-25A5A7464A08}"/>
+                <ns2:creationId id="{3EACDB18-AA92-46D2-8550-1B4759E64505}"/>
               </ns1:ext>
             </ns1:extLst>
           </p:cNvPr>
@@ -4962,7 +4962,7 @@
           <p:cNvPr id="3" name="">
             <ns1:extLst>
               <ns1:ext uri="{FF2B5EF4-FFF2-40B4-BE49-F238E27FC236}">
-                <ns2:creationId id="{705412C2-8B02-4315-99DD-E4733A3D0829}"/>
+                <ns2:creationId id="{454FA596-7ACA-45CF-B158-439B8CA27686}"/>
               </ns1:ext>
             </ns1:extLst>
           </p:cNvPr>
@@ -5110,7 +5110,7 @@
     </p:spTree>
     <p:extLst>
       <p:ext uri="{BB962C8B-B14F-4D97-AF65-F5344CB8AC3E}">
-        <ns3:creationId val="1052799414"/>
+        <ns3:creationId val="897720626"/>
       </p:ext>
     </p:extLst>
   </p:cSld>
@@ -5144,7 +5144,7 @@
           <p:cNvPr id="4" name="">
             <ns1:extLst>
               <ns1:ext uri="{FF2B5EF4-FFF2-40B4-BE49-F238E27FC236}">
-                <ns2:creationId id="{2D71B3B8-7806-41F0-805F-99BB147D937E}"/>
+                <ns2:creationId id="{68E6FD1F-5862-4D92-87B4-E61879CBA2EB}"/>
               </ns1:ext>
             </ns1:extLst>
           </p:cNvPr>
@@ -5210,7 +5210,7 @@
           <p:cNvPr id="2" name="">
             <ns1:extLst>
               <ns1:ext uri="{FF2B5EF4-FFF2-40B4-BE49-F238E27FC236}">
-                <ns2:creationId id="{CF33A0CB-7F65-4B6B-BE86-E5C8B662FE6D}"/>
+                <ns2:creationId id="{6A241441-A639-4EEB-B1CD-9DB30473DFA5}"/>
               </ns1:ext>
             </ns1:extLst>
           </p:cNvPr>
@@ -5276,7 +5276,7 @@
           <p:cNvPr id="3" name="">
             <ns1:extLst>
               <ns1:ext uri="{FF2B5EF4-FFF2-40B4-BE49-F238E27FC236}">
-                <ns2:creationId id="{9C2A39AD-6A9E-4BE0-BF32-A75583206A72}"/>
+                <ns2:creationId id="{F5D4D559-9ACB-4D20-BC82-E82722E0CF5B}"/>
               </ns1:ext>
             </ns1:extLst>
           </p:cNvPr>
@@ -5396,7 +5396,7 @@
     </p:spTree>
     <p:extLst>
       <p:ext uri="{BB962C8B-B14F-4D97-AF65-F5344CB8AC3E}">
-        <ns3:creationId val="434774029"/>
+        <ns3:creationId val="2039794400"/>
       </p:ext>
     </p:extLst>
   </p:cSld>
@@ -5430,7 +5430,7 @@
           <p:cNvPr id="4" name="">
             <ns1:extLst>
               <ns1:ext uri="{FF2B5EF4-FFF2-40B4-BE49-F238E27FC236}">
-                <ns2:creationId id="{0D8D2DE5-FBA9-4C3F-8602-94B3BF3D4E7B}"/>
+                <ns2:creationId id="{B787CA81-051B-4A45-A03C-3A9FC13CE922}"/>
               </ns1:ext>
             </ns1:extLst>
           </p:cNvPr>
@@ -5496,7 +5496,7 @@
           <p:cNvPr id="2" name="">
             <ns1:extLst>
               <ns1:ext uri="{FF2B5EF4-FFF2-40B4-BE49-F238E27FC236}">
-                <ns2:creationId id="{ED8A0811-DF14-48F4-9DC1-86324F1BD92B}"/>
+                <ns2:creationId id="{447F7E40-C1F8-44EB-8F83-79C9BE26A21F}"/>
               </ns1:ext>
             </ns1:extLst>
           </p:cNvPr>
@@ -5552,7 +5552,7 @@
                 <ns1:ea typeface="Helvetica Neue"/>
                 <ns1:cs typeface="Helvetica Neue"/>
               </ns1:rPr>
-              <ns1:t>Proposed grading for SBTE review</ns1:t>
+              <ns1:t>Teacher-only proposal: confirm with Pat</ns1:t>
             </ns1:r>
           </ns1:p>
         </p:txBody>
@@ -5562,7 +5562,7 @@
           <p:cNvPr id="3" name="">
             <ns1:extLst>
               <ns1:ext uri="{FF2B5EF4-FFF2-40B4-BE49-F238E27FC236}">
-                <ns2:creationId id="{AB969B2B-41DD-4396-8242-1FD5C20DC598}"/>
+                <ns2:creationId id="{6C7242AD-ACB8-42F4-A7F9-F0B8162FBF84}"/>
               </ns1:ext>
             </ns1:extLst>
           </p:cNvPr>
@@ -5618,12 +5618,7 @@
                 <ns1:ea typeface="Helvetica Neue"/>
                 <ns1:cs typeface="Helvetica Neue"/>
               </ns1:rPr>
-              <ns1:t>SAY: “A 3 shows complete, accurate application. A 4 explains a deeper decision and why it makes sense. More words alone do not earn a 4.”</ns1:t>
-            </ns1:r>
-          </ns1:p>
-          <ns1:p>
-            <ns1:r>
-              <ns1:t/>
+              <ns1:t>3  Proficient</ns1:t>
             </ns1:r>
           </ns1:p>
           <ns1:p>
@@ -5646,7 +5641,86 @@
                 <ns1:ea typeface="Helvetica Neue"/>
                 <ns1:cs typeface="Helvetica Neue"/>
               </ns1:rPr>
-              <ns1:t>CHECK WITH PAT: Confirm these descriptors and whether this is formative or graded before announcing them as final. No automatic averaging, bonuses, or conversion rules.</ns1:t>
+              <ns1:t>Accurate PEST categories, relevant examples, + and − impacts explained in complete thoughts, and a clear business response.</ns1:t>
+            </ns1:r>
+          </ns1:p>
+          <ns1:p>
+            <ns1:r>
+              <ns1:t/>
+            </ns1:r>
+          </ns1:p>
+          <ns1:p>
+            <ns1:pPr>
+              <ns1:defRPr sz="1875" b="0">
+                <ns1:solidFill>
+                  <ns1:srgbClr val="142C40"/>
+                </ns1:solidFill>
+                <ns1:latin typeface="Helvetica Neue"/>
+                <ns1:ea typeface="Helvetica Neue"/>
+                <ns1:cs typeface="Helvetica Neue"/>
+              </ns1:defRPr>
+            </ns1:pPr>
+            <ns1:r>
+              <ns1:rPr sz="1875" b="0">
+                <ns1:solidFill>
+                  <ns1:srgbClr val="142C40"/>
+                </ns1:solidFill>
+                <ns1:latin typeface="Helvetica Neue"/>
+                <ns1:ea typeface="Helvetica Neue"/>
+                <ns1:cs typeface="Helvetica Neue"/>
+              </ns1:rPr>
+              <ns1:t>4  Exceeds</ns1:t>
+            </ns1:r>
+          </ns1:p>
+          <ns1:p>
+            <ns1:pPr>
+              <ns1:defRPr sz="1875" b="0">
+                <ns1:solidFill>
+                  <ns1:srgbClr val="142C40"/>
+                </ns1:solidFill>
+                <ns1:latin typeface="Helvetica Neue"/>
+                <ns1:ea typeface="Helvetica Neue"/>
+                <ns1:cs typeface="Helvetica Neue"/>
+              </ns1:defRPr>
+            </ns1:pPr>
+            <ns1:r>
+              <ns1:rPr sz="1875" b="0">
+                <ns1:solidFill>
+                  <ns1:srgbClr val="142C40"/>
+                </ns1:solidFill>
+                <ns1:latin typeface="Helvetica Neue"/>
+                <ns1:ea typeface="Helvetica Neue"/>
+                <ns1:cs typeface="Helvetica Neue"/>
+              </ns1:rPr>
+              <ns1:t>Meets level 3 and independently explains a justified priority, trade-off, or connection between factors.</ns1:t>
+            </ns1:r>
+          </ns1:p>
+          <ns1:p>
+            <ns1:r>
+              <ns1:t/>
+            </ns1:r>
+          </ns1:p>
+          <ns1:p>
+            <ns1:pPr>
+              <ns1:defRPr sz="1875" b="0">
+                <ns1:solidFill>
+                  <ns1:srgbClr val="142C40"/>
+                </ns1:solidFill>
+                <ns1:latin typeface="Helvetica Neue"/>
+                <ns1:ea typeface="Helvetica Neue"/>
+                <ns1:cs typeface="Helvetica Neue"/>
+              </ns1:defRPr>
+            </ns1:pPr>
+            <ns1:r>
+              <ns1:rPr sz="1875" b="0">
+                <ns1:solidFill>
+                  <ns1:srgbClr val="142C40"/>
+                </ns1:solidFill>
+                <ns1:latin typeface="Helvetica Neue"/>
+                <ns1:ea typeface="Helvetica Neue"/>
+                <ns1:cs typeface="Helvetica Neue"/>
+              </ns1:rPr>
+              <ns1:t>Announce numerical levels only after Pat approves them.</ns1:t>
             </ns1:r>
           </ns1:p>
         </p:txBody>
@@ -5654,7 +5728,7 @@
     </p:spTree>
     <p:extLst>
       <p:ext uri="{BB962C8B-B14F-4D97-AF65-F5344CB8AC3E}">
-        <ns3:creationId val="1446806983"/>
+        <ns3:creationId val="1939602"/>
       </p:ext>
     </p:extLst>
   </p:cSld>
@@ -5688,7 +5762,7 @@
           <p:cNvPr id="4" name="">
             <ns1:extLst>
               <ns1:ext uri="{FF2B5EF4-FFF2-40B4-BE49-F238E27FC236}">
-                <ns2:creationId id="{602ACB37-D0EC-4A84-8E19-DDC926B6D0A5}"/>
+                <ns2:creationId id="{D1B04F10-3688-42EC-8155-3728AC178D05}"/>
               </ns1:ext>
             </ns1:extLst>
           </p:cNvPr>
@@ -5754,7 +5828,7 @@
           <p:cNvPr id="2" name="">
             <ns1:extLst>
               <ns1:ext uri="{FF2B5EF4-FFF2-40B4-BE49-F238E27FC236}">
-                <ns2:creationId id="{11F0BF39-C458-43B5-A10C-5DB5A6E14A89}"/>
+                <ns2:creationId id="{48C65D1E-90A8-4A5B-B208-BF1BED02A79B}"/>
               </ns1:ext>
             </ns1:extLst>
           </p:cNvPr>
@@ -5810,7 +5884,7 @@
                 <ns1:ea typeface="Helvetica Neue"/>
                 <ns1:cs typeface="Helvetica Neue"/>
               </ns1:rPr>
-              <ns1:t>Explain the impact, not just a keyword</ns1:t>
+              <ns1:t>Teacher-only proposal: confirm with Pat</ns1:t>
             </ns1:r>
           </ns1:p>
         </p:txBody>
@@ -5820,7 +5894,7 @@
           <p:cNvPr id="3" name="">
             <ns1:extLst>
               <ns1:ext uri="{FF2B5EF4-FFF2-40B4-BE49-F238E27FC236}">
-                <ns2:creationId id="{43529470-B70E-4E35-85E3-5CA846FB5571}"/>
+                <ns2:creationId id="{4227F0B5-4DBF-49E1-AE84-E9739F40D47B}"/>
               </ns1:ext>
             </ns1:extLst>
           </p:cNvPr>
@@ -5876,12 +5950,7 @@
                 <ns1:ea typeface="Helvetica Neue"/>
                 <ns1:cs typeface="Helvetica Neue"/>
               </ns1:rPr>
-              <ns1:t>SAY: “Use business terms and explain because. A list of words does not yet show why a business is affected.”</ns1:t>
-            </ns1:r>
-          </ns1:p>
-          <ns1:p>
-            <ns1:r>
-              <ns1:t/>
+              <ns1:t>2  Developing</ns1:t>
             </ns1:r>
           </ns1:p>
           <ns1:p>
@@ -5904,7 +5973,7 @@
                 <ns1:ea typeface="Helvetica Neue"/>
                 <ns1:cs typeface="Helvetica Neue"/>
               </ns1:rPr>
-              <ns1:t>DO: Read directions aloud and accept a spoken rehearsal before writing.</ns1:t>
+              <ns1:t>Some relevant ideas, but impacts or business connections are incomplete or unclear.</ns1:t>
             </ns1:r>
           </ns1:p>
           <ns1:p>
@@ -5932,7 +6001,86 @@
                 <ns1:ea typeface="Helvetica Neue"/>
                 <ns1:cs typeface="Helvetica Neue"/>
               </ns1:rPr>
-              <ns1:t>ASSESS: Understanding, not spelling, handwriting, accent, speed, or decorative work. Access support alone never reduces a level. Insufficient evidence is separate from level 1; confirm IE and overall-score handling with Pat.</ns1:t>
+              <ns1:t>1  Initial</ns1:t>
+            </ns1:r>
+          </ns1:p>
+          <ns1:p>
+            <ns1:pPr>
+              <ns1:defRPr sz="1875" b="0">
+                <ns1:solidFill>
+                  <ns1:srgbClr val="142C40"/>
+                </ns1:solidFill>
+                <ns1:latin typeface="Helvetica Neue"/>
+                <ns1:ea typeface="Helvetica Neue"/>
+                <ns1:cs typeface="Helvetica Neue"/>
+              </ns1:defRPr>
+            </ns1:pPr>
+            <ns1:r>
+              <ns1:rPr sz="1875" b="0">
+                <ns1:solidFill>
+                  <ns1:srgbClr val="142C40"/>
+                </ns1:solidFill>
+                <ns1:latin typeface="Helvetica Neue"/>
+                <ns1:ea typeface="Helvetica Neue"/>
+                <ns1:cs typeface="Helvetica Neue"/>
+              </ns1:rPr>
+              <ns1:t>Limited relevant evidence so far; substantial support needed to explain the effects.</ns1:t>
+            </ns1:r>
+          </ns1:p>
+          <ns1:p>
+            <ns1:r>
+              <ns1:t/>
+            </ns1:r>
+          </ns1:p>
+          <ns1:p>
+            <ns1:pPr>
+              <ns1:defRPr sz="1875" b="0">
+                <ns1:solidFill>
+                  <ns1:srgbClr val="142C40"/>
+                </ns1:solidFill>
+                <ns1:latin typeface="Helvetica Neue"/>
+                <ns1:ea typeface="Helvetica Neue"/>
+                <ns1:cs typeface="Helvetica Neue"/>
+              </ns1:defRPr>
+            </ns1:pPr>
+            <ns1:r>
+              <ns1:rPr sz="1875" b="0">
+                <ns1:solidFill>
+                  <ns1:srgbClr val="142C40"/>
+                </ns1:solidFill>
+                <ns1:latin typeface="Helvetica Neue"/>
+                <ns1:ea typeface="Helvetica Neue"/>
+                <ns1:cs typeface="Helvetica Neue"/>
+              </ns1:rPr>
+              <ns1:t>Use your textbook and notes. Ask for clarification.</ns1:t>
+            </ns1:r>
+          </ns1:p>
+          <ns1:p>
+            <ns1:r>
+              <ns1:t/>
+            </ns1:r>
+          </ns1:p>
+          <ns1:p>
+            <ns1:pPr>
+              <ns1:defRPr sz="1875" b="0">
+                <ns1:solidFill>
+                  <ns1:srgbClr val="142C40"/>
+                </ns1:solidFill>
+                <ns1:latin typeface="Helvetica Neue"/>
+                <ns1:ea typeface="Helvetica Neue"/>
+                <ns1:cs typeface="Helvetica Neue"/>
+              </ns1:defRPr>
+            </ns1:pPr>
+            <ns1:r>
+              <ns1:rPr sz="1875" b="0">
+                <ns1:solidFill>
+                  <ns1:srgbClr val="142C40"/>
+                </ns1:solidFill>
+                <ns1:latin typeface="Helvetica Neue"/>
+                <ns1:ea typeface="Helvetica Neue"/>
+                <ns1:cs typeface="Helvetica Neue"/>
+              </ns1:rPr>
+              <ns1:t>Announce numerical levels only after Pat approves them.</ns1:t>
             </ns1:r>
           </ns1:p>
         </p:txBody>
@@ -5940,7 +6088,7 @@
     </p:spTree>
     <p:extLst>
       <p:ext uri="{BB962C8B-B14F-4D97-AF65-F5344CB8AC3E}">
-        <ns3:creationId val="1106482971"/>
+        <ns3:creationId val="2062321925"/>
       </p:ext>
     </p:extLst>
   </p:cSld>
@@ -5974,7 +6122,7 @@
           <p:cNvPr id="4" name="">
             <ns1:extLst>
               <ns1:ext uri="{FF2B5EF4-FFF2-40B4-BE49-F238E27FC236}">
-                <ns2:creationId id="{DF36E27F-94CE-4C18-A2C9-9800CF9DDA31}"/>
+                <ns2:creationId id="{1AD8583A-672B-4A00-9186-E1AA3C417298}"/>
               </ns1:ext>
             </ns1:extLst>
           </p:cNvPr>
@@ -6040,7 +6188,7 @@
           <p:cNvPr id="2" name="">
             <ns1:extLst>
               <ns1:ext uri="{FF2B5EF4-FFF2-40B4-BE49-F238E27FC236}">
-                <ns2:creationId id="{36A54677-A0CC-4794-B222-E7B9B8041D0E}"/>
+                <ns2:creationId id="{647B4599-AFBB-473E-AFE9-46E83713887E}"/>
               </ns1:ext>
             </ns1:extLst>
           </p:cNvPr>
@@ -6106,7 +6254,7 @@
           <p:cNvPr id="3" name="">
             <ns1:extLst>
               <ns1:ext uri="{FF2B5EF4-FFF2-40B4-BE49-F238E27FC236}">
-                <ns2:creationId id="{5E296A78-BD7B-4202-8BD7-9BF3072B11A3}"/>
+                <ns2:creationId id="{9D684D14-58B3-403C-8F2B-F0AF4963D844}"/>
               </ns1:ext>
             </ns1:extLst>
           </p:cNvPr>
@@ -6226,7 +6374,7 @@
     </p:spTree>
     <p:extLst>
       <p:ext uri="{BB962C8B-B14F-4D97-AF65-F5344CB8AC3E}">
-        <ns3:creationId val="2055390681"/>
+        <ns3:creationId val="1775026469"/>
       </p:ext>
     </p:extLst>
   </p:cSld>
@@ -6260,7 +6408,7 @@
           <p:cNvPr id="4" name="">
             <ns1:extLst>
               <ns1:ext uri="{FF2B5EF4-FFF2-40B4-BE49-F238E27FC236}">
-                <ns2:creationId id="{4074DDF0-EB75-4E40-8189-F19405F45F81}"/>
+                <ns2:creationId id="{F2549C6E-D51C-4D51-81C8-C0DFB534DAB4}"/>
               </ns1:ext>
             </ns1:extLst>
           </p:cNvPr>
@@ -6326,7 +6474,7 @@
           <p:cNvPr id="2" name="">
             <ns1:extLst>
               <ns1:ext uri="{FF2B5EF4-FFF2-40B4-BE49-F238E27FC236}">
-                <ns2:creationId id="{72AC47B6-ADFD-40C1-9D26-950BCAD01CA0}"/>
+                <ns2:creationId id="{5EF8C05B-F9A5-496C-8496-941C256BAF5F}"/>
               </ns1:ext>
             </ns1:extLst>
           </p:cNvPr>
@@ -6392,7 +6540,7 @@
           <p:cNvPr id="3" name="">
             <ns1:extLst>
               <ns1:ext uri="{FF2B5EF4-FFF2-40B4-BE49-F238E27FC236}">
-                <ns2:creationId id="{CDF7D892-3F8F-44E5-9EE1-6B5874D02609}"/>
+                <ns2:creationId id="{32AB6E77-9826-4184-B1A3-FB6B0ED415AD}"/>
               </ns1:ext>
             </ns1:extLst>
           </p:cNvPr>
@@ -6512,7 +6660,7 @@
     </p:spTree>
     <p:extLst>
       <p:ext uri="{BB962C8B-B14F-4D97-AF65-F5344CB8AC3E}">
-        <ns3:creationId val="593249840"/>
+        <ns3:creationId val="989419859"/>
       </p:ext>
     </p:extLst>
   </p:cSld>
@@ -6546,7 +6694,7 @@
           <p:cNvPr id="4" name="">
             <ns1:extLst>
               <ns1:ext uri="{FF2B5EF4-FFF2-40B4-BE49-F238E27FC236}">
-                <ns2:creationId id="{70B7F621-4805-43B5-8D2A-96935E08C84A}"/>
+                <ns2:creationId id="{852F8CBE-090F-4E13-AF48-8594857FE4A4}"/>
               </ns1:ext>
             </ns1:extLst>
           </p:cNvPr>
@@ -6612,7 +6760,7 @@
           <p:cNvPr id="2" name="">
             <ns1:extLst>
               <ns1:ext uri="{FF2B5EF4-FFF2-40B4-BE49-F238E27FC236}">
-                <ns2:creationId id="{4440CC2F-7CEA-45D9-B512-FA26A00BB972}"/>
+                <ns2:creationId id="{A6AED6ED-6638-46E3-B92B-049D21FB59EA}"/>
               </ns1:ext>
             </ns1:extLst>
           </p:cNvPr>
@@ -6678,7 +6826,7 @@
           <p:cNvPr id="3" name="">
             <ns1:extLst>
               <ns1:ext uri="{FF2B5EF4-FFF2-40B4-BE49-F238E27FC236}">
-                <ns2:creationId id="{D1C90217-369A-42C8-9180-C95E8B53006B}"/>
+                <ns2:creationId id="{1374F7DB-6C6F-4A05-A7E6-62F09740FB43}"/>
               </ns1:ext>
             </ns1:extLst>
           </p:cNvPr>
@@ -6882,7 +7030,7 @@
     </p:spTree>
     <p:extLst>
       <p:ext uri="{BB962C8B-B14F-4D97-AF65-F5344CB8AC3E}">
-        <ns3:creationId val="1086263602"/>
+        <ns3:creationId val="364509068"/>
       </p:ext>
     </p:extLst>
   </p:cSld>
@@ -6916,7 +7064,7 @@
           <p:cNvPr id="4" name="">
             <ns1:extLst>
               <ns1:ext uri="{FF2B5EF4-FFF2-40B4-BE49-F238E27FC236}">
-                <ns2:creationId id="{8C68FBBF-FFF1-44EC-BCE0-CABDA771393B}"/>
+                <ns2:creationId id="{F3D3D98B-E305-4C6C-95EC-88DBEB5B5F2E}"/>
               </ns1:ext>
             </ns1:extLst>
           </p:cNvPr>
@@ -6982,7 +7130,7 @@
           <p:cNvPr id="2" name="">
             <ns1:extLst>
               <ns1:ext uri="{FF2B5EF4-FFF2-40B4-BE49-F238E27FC236}">
-                <ns2:creationId id="{F7B7E547-6C71-4929-BC52-16D78E5B70F4}"/>
+                <ns2:creationId id="{D9CC3AE8-C916-4255-8355-B7A98E2273CE}"/>
               </ns1:ext>
             </ns1:extLst>
           </p:cNvPr>
@@ -7048,7 +7196,7 @@
           <p:cNvPr id="3" name="">
             <ns1:extLst>
               <ns1:ext uri="{FF2B5EF4-FFF2-40B4-BE49-F238E27FC236}">
-                <ns2:creationId id="{F9A8EF45-1AB3-4523-A53A-12431095C954}"/>
+                <ns2:creationId id="{77AB5B4B-4491-4E41-839C-30EAA9C5F274}"/>
               </ns1:ext>
             </ns1:extLst>
           </p:cNvPr>
@@ -7252,7 +7400,7 @@
     </p:spTree>
     <p:extLst>
       <p:ext uri="{BB962C8B-B14F-4D97-AF65-F5344CB8AC3E}">
-        <ns3:creationId val="1450290026"/>
+        <ns3:creationId val="1403103225"/>
       </p:ext>
     </p:extLst>
   </p:cSld>
@@ -7286,7 +7434,7 @@
           <p:cNvPr id="4" name="">
             <ns1:extLst>
               <ns1:ext uri="{FF2B5EF4-FFF2-40B4-BE49-F238E27FC236}">
-                <ns2:creationId id="{DBF82DC0-916E-4EEE-98EB-56D7C4BB3CD5}"/>
+                <ns2:creationId id="{F4C7A773-1456-42F7-B623-8694D1DE1CDF}"/>
               </ns1:ext>
             </ns1:extLst>
           </p:cNvPr>
@@ -7352,7 +7500,7 @@
           <p:cNvPr id="2" name="">
             <ns1:extLst>
               <ns1:ext uri="{FF2B5EF4-FFF2-40B4-BE49-F238E27FC236}">
-                <ns2:creationId id="{836DDBB3-A62B-4272-A534-822CC4ADF27D}"/>
+                <ns2:creationId id="{0C43D7C6-8694-4311-AFCE-F2ECB3D3B52C}"/>
               </ns1:ext>
             </ns1:extLst>
           </p:cNvPr>
@@ -7418,7 +7566,7 @@
           <p:cNvPr id="3" name="">
             <ns1:extLst>
               <ns1:ext uri="{FF2B5EF4-FFF2-40B4-BE49-F238E27FC236}">
-                <ns2:creationId id="{527C5F3F-996B-4EDE-9EC9-633EB3BF026A}"/>
+                <ns2:creationId id="{4E67B587-8F39-4BB5-BBBB-4C1E87426DDE}"/>
               </ns1:ext>
             </ns1:extLst>
           </p:cNvPr>
@@ -7622,7 +7770,7 @@
     </p:spTree>
     <p:extLst>
       <p:ext uri="{BB962C8B-B14F-4D97-AF65-F5344CB8AC3E}">
-        <ns3:creationId val="176160057"/>
+        <ns3:creationId val="2040194174"/>
       </p:ext>
     </p:extLst>
   </p:cSld>

</xml_diff>